<commit_message>
feat(slides): reestructura al outline de 15 diapositivas de la exposición oral
- Secuencia: empresa, problemática, impacto, causa raíz, estrategia,
  solución (ER), gestión de datos, automatización, reglas de negocio,
  inventario, integración op/tec, estrategia integral, beneficios, conclusión
- Redacción de problemática, impacto y causa raíz según el caso real
- Portada con Integrantes/Materia/Profesor; evidencias como placeholders
- Mantiene estilo monocromático y logo solo en portada
</commit_message>
<xml_diff>
--- a/docs/latex/slides/slides.pptx
+++ b/docs/latex/slides/slides.pptx
@@ -22,7 +22,6 @@
     <p:sldId id="270" r:id="rId21"/>
     <p:sldId id="271" r:id="rId22"/>
     <p:sldId id="272" r:id="rId23"/>
-    <p:sldId id="273" r:id="rId24"/>
   </p:sldIdLst>
   <p:sldSz cx="12191695" cy="6858000" type="screen4x3"/>
   <p:notesSz cx="6858000" cy="9144000"/>
@@ -3145,8 +3144,8 @@
         </p:nvSpPr>
         <p:spPr>
           <a:xfrm>
-            <a:off x="914400" y="2377440"/>
-            <a:ext cx="10362895" cy="2194560"/>
+            <a:off x="914400" y="2194560"/>
+            <a:ext cx="10362895" cy="2560320"/>
           </a:xfrm>
           <a:prstGeom prst="rect">
             <a:avLst/>
@@ -3161,11 +3160,11 @@
           <a:p>
             <a:pPr algn="ctr">
               <a:spcAft>
-                <a:spcPts val="600"/>
+                <a:spcPts val="500"/>
               </a:spcAft>
             </a:pPr>
             <a:r>
-              <a:rPr sz="4000" b="1">
+              <a:rPr sz="3800" b="1">
                 <a:solidFill>
                   <a:srgbClr val="000000"/>
                 </a:solidFill>
@@ -3177,7 +3176,7 @@
           <a:p>
             <a:pPr algn="ctr">
               <a:spcAft>
-                <a:spcPts val="600"/>
+                <a:spcPts val="500"/>
               </a:spcAft>
             </a:pPr>
             <a:r>
@@ -3187,17 +3186,17 @@
                 </a:solidFill>
                 <a:latin typeface="Arial"/>
               </a:rPr>
-              <a:t>Presentación Técnica del Proyecto Final — Base de Datos Relacional</a:t>
+              <a:t>Gestión de Consultas y Medicamentos Recetados</a:t>
             </a:r>
           </a:p>
           <a:p>
             <a:pPr algn="ctr">
               <a:spcAft>
-                <a:spcPts val="600"/>
+                <a:spcPts val="500"/>
               </a:spcAft>
             </a:pPr>
             <a:r>
-              <a:rPr sz="1000" b="0">
+              <a:rPr sz="1200" b="0">
                 <a:solidFill>
                   <a:srgbClr val="000000"/>
                 </a:solidFill>
@@ -3209,7 +3208,7 @@
           <a:p>
             <a:pPr algn="ctr">
               <a:spcAft>
-                <a:spcPts val="600"/>
+                <a:spcPts val="500"/>
               </a:spcAft>
             </a:pPr>
             <a:r>
@@ -3219,17 +3218,49 @@
                 </a:solidFill>
                 <a:latin typeface="Arial"/>
               </a:rPr>
-              <a:t>[Tu Nombre]  |  LSTI2311: Bases de Datos</a:t>
+              <a:t>[Integrantes]</a:t>
             </a:r>
           </a:p>
           <a:p>
             <a:pPr algn="ctr">
               <a:spcAft>
-                <a:spcPts val="600"/>
+                <a:spcPts val="500"/>
               </a:spcAft>
             </a:pPr>
             <a:r>
-              <a:rPr sz="1400" b="0">
+              <a:rPr sz="1600" b="0">
+                <a:solidFill>
+                  <a:srgbClr val="000000"/>
+                </a:solidFill>
+                <a:latin typeface="Arial"/>
+              </a:rPr>
+              <a:t>LSTI2311: Bases de Datos</a:t>
+            </a:r>
+          </a:p>
+          <a:p>
+            <a:pPr algn="ctr">
+              <a:spcAft>
+                <a:spcPts val="500"/>
+              </a:spcAft>
+            </a:pPr>
+            <a:r>
+              <a:rPr sz="1600" b="0">
+                <a:solidFill>
+                  <a:srgbClr val="000000"/>
+                </a:solidFill>
+                <a:latin typeface="Arial"/>
+              </a:rPr>
+              <a:t>Prof. [Profesor]</a:t>
+            </a:r>
+          </a:p>
+          <a:p>
+            <a:pPr algn="ctr">
+              <a:spcAft>
+                <a:spcPts val="500"/>
+              </a:spcAft>
+            </a:pPr>
+            <a:r>
+              <a:rPr sz="1300" b="0">
                 <a:solidFill>
                   <a:srgbClr val="404040"/>
                 </a:solidFill>
@@ -3274,7 +3305,7 @@
         </p:nvSpPr>
         <p:spPr>
           <a:xfrm>
-            <a:off x="640080" y="411480"/>
+            <a:off x="640080" y="365760"/>
             <a:ext cx="10911535" cy="822960"/>
           </a:xfrm>
           <a:prstGeom prst="rect">
@@ -3289,13 +3320,13 @@
           <a:lstStyle/>
           <a:p>
             <a:r>
-              <a:rPr sz="3000" b="1">
-                <a:solidFill>
-                  <a:srgbClr val="000000"/>
-                </a:solidFill>
-                <a:latin typeface="Arial"/>
-              </a:rPr>
-              <a:t>Modelo Entidad-Relación: estructura</a:t>
+              <a:rPr sz="2800" b="1">
+                <a:solidFill>
+                  <a:srgbClr val="000000"/>
+                </a:solidFill>
+                <a:latin typeface="Arial"/>
+              </a:rPr>
+              <a:t>¿Cómo automatizamos los procesos?</a:t>
             </a:r>
           </a:p>
         </p:txBody>
@@ -3308,7 +3339,7 @@
         </p:nvCxnSpPr>
         <p:spPr>
           <a:xfrm>
-            <a:off x="640080" y="1261872"/>
+            <a:off x="640080" y="1170432"/>
             <a:ext cx="4754880" cy="0"/>
           </a:xfrm>
           <a:prstGeom prst="line">
@@ -3343,8 +3374,8 @@
         </p:nvSpPr>
         <p:spPr>
           <a:xfrm>
-            <a:off x="640080" y="1554480"/>
-            <a:ext cx="10911535" cy="4206240"/>
+            <a:off x="640080" y="1371600"/>
+            <a:ext cx="10911535" cy="2926080"/>
           </a:xfrm>
           <a:prstGeom prst="rect">
             <a:avLst/>
@@ -3357,117 +3388,200 @@
           </a:bodyPr>
           <a:lstStyle/>
           <a:p>
-            <a:r>
-              <a:rPr b="1" sz="2000">
-                <a:solidFill>
-                  <a:srgbClr val="000000"/>
-                </a:solidFill>
-                <a:latin typeface="Arial"/>
-              </a:rPr>
-              <a:t>20 tablas organizadas en:</a:t>
-            </a:r>
-          </a:p>
-          <a:p>
-            <a:pPr lvl="1">
+            <a:pPr>
               <a:spcAft>
-                <a:spcPts val="600"/>
+                <a:spcPts val="400"/>
               </a:spcAft>
             </a:pPr>
             <a:r>
-              <a:rPr sz="1800">
-                <a:solidFill>
-                  <a:srgbClr val="000000"/>
-                </a:solidFill>
-                <a:latin typeface="Arial"/>
-              </a:rPr>
-              <a:t>– Personas: Empleados, Médicos, Pacientes.</a:t>
-            </a:r>
-          </a:p>
-          <a:p>
-            <a:pPr lvl="1">
+              <a:rPr sz="1700">
+                <a:solidFill>
+                  <a:srgbClr val="000000"/>
+                </a:solidFill>
+                <a:latin typeface="Arial"/>
+              </a:rPr>
+              <a:t>– </a:t>
+            </a:r>
+            <a:r>
+              <a:rPr b="1" sz="1700">
+                <a:solidFill>
+                  <a:srgbClr val="000000"/>
+                </a:solidFill>
+                <a:latin typeface="Arial"/>
+              </a:rPr>
+              <a:t>Vistas:</a:t>
+            </a:r>
+            <a:r>
+              <a:rPr sz="1700">
+                <a:solidFill>
+                  <a:srgbClr val="000000"/>
+                </a:solidFill>
+                <a:latin typeface="Arial"/>
+              </a:rPr>
+              <a:t> historial clínico, inventario con alertas y medicamentos más recetados/surtidos.</a:t>
+            </a:r>
+          </a:p>
+          <a:p>
+            <a:pPr>
               <a:spcAft>
-                <a:spcPts val="600"/>
+                <a:spcPts val="400"/>
               </a:spcAft>
             </a:pPr>
             <a:r>
-              <a:rPr sz="1800">
-                <a:solidFill>
-                  <a:srgbClr val="000000"/>
-                </a:solidFill>
-                <a:latin typeface="Arial"/>
-              </a:rPr>
-              <a:t>– Clínico: Historiales, Condiciones, Consultas, Recetas.</a:t>
-            </a:r>
-          </a:p>
-          <a:p>
-            <a:pPr lvl="1">
+              <a:rPr sz="1700">
+                <a:solidFill>
+                  <a:srgbClr val="000000"/>
+                </a:solidFill>
+                <a:latin typeface="Arial"/>
+              </a:rPr>
+              <a:t>– </a:t>
+            </a:r>
+            <a:r>
+              <a:rPr b="1" sz="1700">
+                <a:solidFill>
+                  <a:srgbClr val="000000"/>
+                </a:solidFill>
+                <a:latin typeface="Arial"/>
+              </a:rPr>
+              <a:t>Stored Procedures:</a:t>
+            </a:r>
+            <a:r>
+              <a:rPr sz="1700">
+                <a:solidFill>
+                  <a:srgbClr val="000000"/>
+                </a:solidFill>
+                <a:latin typeface="Arial"/>
+              </a:rPr>
+              <a:t> registrar consulta/receta, surtir receta y generar reposición.</a:t>
+            </a:r>
+          </a:p>
+          <a:p>
+            <a:pPr>
               <a:spcAft>
-                <a:spcPts val="600"/>
+                <a:spcPts val="400"/>
               </a:spcAft>
             </a:pPr>
             <a:r>
-              <a:rPr sz="1800">
-                <a:solidFill>
-                  <a:srgbClr val="000000"/>
-                </a:solidFill>
-                <a:latin typeface="Arial"/>
-              </a:rPr>
-              <a:t>– Farmacia: Medicamentos, Lotes, Inventario.</a:t>
-            </a:r>
-          </a:p>
-          <a:p>
-            <a:pPr lvl="1">
+              <a:rPr sz="1700">
+                <a:solidFill>
+                  <a:srgbClr val="000000"/>
+                </a:solidFill>
+                <a:latin typeface="Arial"/>
+              </a:rPr>
+              <a:t>– </a:t>
+            </a:r>
+            <a:r>
+              <a:rPr b="1" sz="1700">
+                <a:solidFill>
+                  <a:srgbClr val="000000"/>
+                </a:solidFill>
+                <a:latin typeface="Arial"/>
+              </a:rPr>
+              <a:t>Triggers:</a:t>
+            </a:r>
+            <a:r>
+              <a:rPr sz="1700">
+                <a:solidFill>
+                  <a:srgbClr val="000000"/>
+                </a:solidFill>
+                <a:latin typeface="Arial"/>
+              </a:rPr>
+              <a:t> validan recetas y disparan la auditoría de inventario.</a:t>
+            </a:r>
+          </a:p>
+          <a:p>
+            <a:pPr>
               <a:spcAft>
-                <a:spcPts val="600"/>
+                <a:spcPts val="400"/>
               </a:spcAft>
             </a:pPr>
             <a:r>
-              <a:rPr sz="1800">
-                <a:solidFill>
-                  <a:srgbClr val="000000"/>
-                </a:solidFill>
-                <a:latin typeface="Arial"/>
-              </a:rPr>
-              <a:t>– Comercial: Ventas, Proveedores, Órdenes de Compra.</a:t>
-            </a:r>
-          </a:p>
-          <a:p>
-            <a:pPr lvl="1">
-              <a:spcAft>
-                <a:spcPts val="600"/>
-              </a:spcAft>
-            </a:pPr>
-            <a:r>
-              <a:rPr sz="1800">
-                <a:solidFill>
-                  <a:srgbClr val="000000"/>
-                </a:solidFill>
-                <a:latin typeface="Arial"/>
-              </a:rPr>
-              <a:t>– Auditoría: Auditoria_Inventario (LOG).</a:t>
-            </a:r>
-          </a:p>
-          <a:p>
-            <a:pPr>
-              <a:spcBef>
-                <a:spcPts val="1000"/>
-              </a:spcBef>
-            </a:pPr>
-            <a:r>
-              <a:rPr sz="1500">
+              <a:rPr sz="1700">
+                <a:solidFill>
+                  <a:srgbClr val="000000"/>
+                </a:solidFill>
+                <a:latin typeface="Arial"/>
+              </a:rPr>
+              <a:t>– </a:t>
+            </a:r>
+            <a:r>
+              <a:rPr b="1" sz="1700">
+                <a:solidFill>
+                  <a:srgbClr val="000000"/>
+                </a:solidFill>
+                <a:latin typeface="Arial"/>
+              </a:rPr>
+              <a:t>LOG de auditoría:</a:t>
+            </a:r>
+            <a:r>
+              <a:rPr sz="1700">
+                <a:solidFill>
+                  <a:srgbClr val="000000"/>
+                </a:solidFill>
+                <a:latin typeface="Arial"/>
+              </a:rPr>
+              <a:t> tabla Auditoria_Inventario con cada movimiento de stock.</a:t>
+            </a:r>
+          </a:p>
+        </p:txBody>
+      </p:sp>
+      <p:sp>
+        <p:nvSpPr>
+          <p:cNvPr id="5" name="Rectangle 4"/>
+          <p:cNvSpPr/>
+          <p:nvPr/>
+        </p:nvSpPr>
+        <p:spPr>
+          <a:xfrm>
+            <a:off x="1981047" y="4572000"/>
+            <a:ext cx="8229600" cy="1554480"/>
+          </a:xfrm>
+          <a:prstGeom prst="rect">
+            <a:avLst/>
+          </a:prstGeom>
+          <a:solidFill>
+            <a:srgbClr val="FFFFFF"/>
+          </a:solidFill>
+          <a:ln w="12700">
+            <a:solidFill>
+              <a:srgbClr val="000000"/>
+            </a:solidFill>
+          </a:ln>
+        </p:spPr>
+        <p:style>
+          <a:lnRef idx="1">
+            <a:schemeClr val="accent1"/>
+          </a:lnRef>
+          <a:fillRef idx="3">
+            <a:schemeClr val="accent1"/>
+          </a:fillRef>
+          <a:effectRef idx="2">
+            <a:schemeClr val="accent1"/>
+          </a:effectRef>
+          <a:fontRef idx="minor">
+            <a:schemeClr val="lt1"/>
+          </a:fontRef>
+        </p:style>
+        <p:txBody>
+          <a:bodyPr rtlCol="0" anchor="ctr" wrap="square"/>
+          <a:lstStyle/>
+          <a:p>
+            <a:pPr algn="ctr"/>
+            <a:r>
+              <a:rPr i="1" sz="1500">
                 <a:solidFill>
                   <a:srgbClr val="404040"/>
                 </a:solidFill>
                 <a:latin typeface="Arial"/>
               </a:rPr>
-              <a:t>Claves primarias y foráneas por tabla; convención de IDs con prefijo (p. ej. PAC-000001). Normalización 1FN–3FN.</a:t>
-            </a:r>
-          </a:p>
-        </p:txBody>
-      </p:sp>
-      <p:sp>
-        <p:nvSpPr>
-          <p:cNvPr id="5" name="TextBox 4"/>
+              <a:t>[Evidencia: resultados reales de la BD (vistas / SP / triggers)]</a:t>
+            </a:r>
+          </a:p>
+        </p:txBody>
+      </p:sp>
+      <p:sp>
+        <p:nvSpPr>
+          <p:cNvPr id="6" name="TextBox 5"/>
           <p:cNvSpPr txBox="1"/>
           <p:nvPr/>
         </p:nvSpPr>
@@ -3501,7 +3615,7 @@
       </p:sp>
       <p:sp>
         <p:nvSpPr>
-          <p:cNvPr id="6" name="TextBox 5"/>
+          <p:cNvPr id="7" name="TextBox 6"/>
           <p:cNvSpPr txBox="1"/>
           <p:nvPr/>
         </p:nvSpPr>
@@ -3568,7 +3682,7 @@
         </p:nvSpPr>
         <p:spPr>
           <a:xfrm>
-            <a:off x="640080" y="411480"/>
+            <a:off x="640080" y="365760"/>
             <a:ext cx="10911535" cy="822960"/>
           </a:xfrm>
           <a:prstGeom prst="rect">
@@ -3583,13 +3697,13 @@
           <a:lstStyle/>
           <a:p>
             <a:r>
-              <a:rPr sz="3000" b="1">
-                <a:solidFill>
-                  <a:srgbClr val="000000"/>
-                </a:solidFill>
-                <a:latin typeface="Arial"/>
-              </a:rPr>
-              <a:t>¿Cómo ayuda la BD en la gestión de los datos? (Vistas)</a:t>
+              <a:rPr sz="2800" b="1">
+                <a:solidFill>
+                  <a:srgbClr val="000000"/>
+                </a:solidFill>
+                <a:latin typeface="Arial"/>
+              </a:rPr>
+              <a:t>¿Cómo aplicamos las reglas de negocio?</a:t>
             </a:r>
           </a:p>
         </p:txBody>
@@ -3602,7 +3716,7 @@
         </p:nvCxnSpPr>
         <p:spPr>
           <a:xfrm>
-            <a:off x="640080" y="1261872"/>
+            <a:off x="640080" y="1170432"/>
             <a:ext cx="4754880" cy="0"/>
           </a:xfrm>
           <a:prstGeom prst="line">
@@ -3637,8 +3751,8 @@
         </p:nvSpPr>
         <p:spPr>
           <a:xfrm>
-            <a:off x="640080" y="1554480"/>
-            <a:ext cx="10911535" cy="2743200"/>
+            <a:off x="640080" y="1371600"/>
+            <a:ext cx="10911535" cy="2926080"/>
           </a:xfrm>
           <a:prstGeom prst="rect">
             <a:avLst/>
@@ -3653,11 +3767,11 @@
           <a:p>
             <a:pPr>
               <a:spcAft>
-                <a:spcPts val="800"/>
+                <a:spcPts val="400"/>
               </a:spcAft>
             </a:pPr>
             <a:r>
-              <a:rPr sz="2000">
+              <a:rPr sz="1700">
                 <a:solidFill>
                   <a:srgbClr val="000000"/>
                 </a:solidFill>
@@ -3666,32 +3780,32 @@
               <a:t>– </a:t>
             </a:r>
             <a:r>
-              <a:rPr b="1" sz="2000">
-                <a:solidFill>
-                  <a:srgbClr val="000000"/>
-                </a:solidFill>
-                <a:latin typeface="Arial"/>
-              </a:rPr>
-              <a:t>Vista 1 — Historial clínico completo del paciente.</a:t>
-            </a:r>
-            <a:r>
-              <a:rPr sz="2000">
-                <a:solidFill>
-                  <a:srgbClr val="000000"/>
-                </a:solidFill>
-                <a:latin typeface="Arial"/>
-              </a:rPr>
-              <a:t> Consolida consultas, diagnósticos, recetas, dosis y alergias.</a:t>
+              <a:rPr b="1" sz="1700">
+                <a:solidFill>
+                  <a:srgbClr val="000000"/>
+                </a:solidFill>
+                <a:latin typeface="Arial"/>
+              </a:rPr>
+              <a:t>Validación de pacientes y médicos:</a:t>
+            </a:r>
+            <a:r>
+              <a:rPr sz="1700">
+                <a:solidFill>
+                  <a:srgbClr val="000000"/>
+                </a:solidFill>
+                <a:latin typeface="Arial"/>
+              </a:rPr>
+              <a:t> paciente activo y médico con cédula vigente.</a:t>
             </a:r>
           </a:p>
           <a:p>
             <a:pPr>
               <a:spcAft>
-                <a:spcPts val="800"/>
+                <a:spcPts val="400"/>
               </a:spcAft>
             </a:pPr>
             <a:r>
-              <a:rPr sz="2000">
+              <a:rPr sz="1700">
                 <a:solidFill>
                   <a:srgbClr val="000000"/>
                 </a:solidFill>
@@ -3700,32 +3814,32 @@
               <a:t>– </a:t>
             </a:r>
             <a:r>
-              <a:rPr b="1" sz="2000">
-                <a:solidFill>
-                  <a:srgbClr val="000000"/>
-                </a:solidFill>
-                <a:latin typeface="Arial"/>
-              </a:rPr>
-              <a:t>Vista 2 — Inventario con alertas de stock mínimo.</a:t>
-            </a:r>
-            <a:r>
-              <a:rPr sz="2000">
-                <a:solidFill>
-                  <a:srgbClr val="000000"/>
-                </a:solidFill>
-                <a:latin typeface="Arial"/>
-              </a:rPr>
-              <a:t> Estado (suficiente/bajo/crítico/agotado), lote y caducidad más próxima.</a:t>
+              <a:rPr b="1" sz="1700">
+                <a:solidFill>
+                  <a:srgbClr val="000000"/>
+                </a:solidFill>
+                <a:latin typeface="Arial"/>
+              </a:rPr>
+              <a:t>Alergias y contraindicaciones:</a:t>
+            </a:r>
+            <a:r>
+              <a:rPr sz="1700">
+                <a:solidFill>
+                  <a:srgbClr val="000000"/>
+                </a:solidFill>
+                <a:latin typeface="Arial"/>
+              </a:rPr>
+              <a:t> se verifican contra los medicamentos recetados.</a:t>
             </a:r>
           </a:p>
           <a:p>
             <a:pPr>
               <a:spcAft>
-                <a:spcPts val="800"/>
+                <a:spcPts val="400"/>
               </a:spcAft>
             </a:pPr>
             <a:r>
-              <a:rPr sz="2000">
+              <a:rPr sz="1700">
                 <a:solidFill>
                   <a:srgbClr val="000000"/>
                 </a:solidFill>
@@ -3734,22 +3848,56 @@
               <a:t>– </a:t>
             </a:r>
             <a:r>
-              <a:rPr b="1" sz="2000">
-                <a:solidFill>
-                  <a:srgbClr val="000000"/>
-                </a:solidFill>
-                <a:latin typeface="Arial"/>
-              </a:rPr>
-              <a:t>Vista 3 — Medicamentos más recetados y surtidos.</a:t>
-            </a:r>
-            <a:r>
-              <a:rPr sz="2000">
-                <a:solidFill>
-                  <a:srgbClr val="000000"/>
-                </a:solidFill>
-                <a:latin typeface="Arial"/>
-              </a:rPr>
-              <a:t> Conversión receta–venta y tendencia de consumo para decidir compras.</a:t>
+              <a:rPr b="1" sz="1700">
+                <a:solidFill>
+                  <a:srgbClr val="000000"/>
+                </a:solidFill>
+                <a:latin typeface="Arial"/>
+              </a:rPr>
+              <a:t>Interacciones medicamentosas:</a:t>
+            </a:r>
+            <a:r>
+              <a:rPr sz="1700">
+                <a:solidFill>
+                  <a:srgbClr val="000000"/>
+                </a:solidFill>
+                <a:latin typeface="Arial"/>
+              </a:rPr>
+              <a:t> se bloquean combinaciones peligrosas.</a:t>
+            </a:r>
+          </a:p>
+          <a:p>
+            <a:pPr>
+              <a:spcAft>
+                <a:spcPts val="400"/>
+              </a:spcAft>
+            </a:pPr>
+            <a:r>
+              <a:rPr sz="1700">
+                <a:solidFill>
+                  <a:srgbClr val="000000"/>
+                </a:solidFill>
+                <a:latin typeface="Arial"/>
+              </a:rPr>
+              <a:t>– </a:t>
+            </a:r>
+            <a:r>
+              <a:rPr b="1" sz="1700">
+                <a:solidFill>
+                  <a:srgbClr val="000000"/>
+                </a:solidFill>
+                <a:latin typeface="Arial"/>
+              </a:rPr>
+              <a:t>Validación de recetas:</a:t>
+            </a:r>
+            <a:r>
+              <a:rPr sz="1700">
+                <a:solidFill>
+                  <a:srgbClr val="000000"/>
+                </a:solidFill>
+                <a:latin typeface="Arial"/>
+              </a:rPr>
+              <a:t> dosis, duración y vigencia dentro de rango.</a:t>
             </a:r>
           </a:p>
         </p:txBody>
@@ -3762,8 +3910,8 @@
         </p:nvSpPr>
         <p:spPr>
           <a:xfrm>
-            <a:off x="1752447" y="4297680"/>
-            <a:ext cx="8686800" cy="1920240"/>
+            <a:off x="1981047" y="4572000"/>
+            <a:ext cx="8229600" cy="1554480"/>
           </a:xfrm>
           <a:prstGeom prst="rect">
             <a:avLst/>
@@ -3797,13 +3945,13 @@
           <a:p>
             <a:pPr algn="ctr"/>
             <a:r>
-              <a:rPr i="1" sz="1600">
+              <a:rPr i="1" sz="1500">
                 <a:solidFill>
                   <a:srgbClr val="404040"/>
                 </a:solidFill>
                 <a:latin typeface="Arial"/>
               </a:rPr>
-              <a:t>[Captura de pantalla: resultado de una vista en MySQL]</a:t>
+              <a:t>[Evidencia: mensaje real de validación/error]</a:t>
             </a:r>
           </a:p>
         </p:txBody>
@@ -3911,7 +4059,7 @@
         </p:nvSpPr>
         <p:spPr>
           <a:xfrm>
-            <a:off x="640080" y="411480"/>
+            <a:off x="640080" y="365760"/>
             <a:ext cx="10911535" cy="822960"/>
           </a:xfrm>
           <a:prstGeom prst="rect">
@@ -3926,13 +4074,13 @@
           <a:lstStyle/>
           <a:p>
             <a:r>
-              <a:rPr sz="3000" b="1">
-                <a:solidFill>
-                  <a:srgbClr val="000000"/>
-                </a:solidFill>
-                <a:latin typeface="Arial"/>
-              </a:rPr>
-              <a:t>Automatización de procesos: Stored Procedures</a:t>
+              <a:rPr sz="2800" b="1">
+                <a:solidFill>
+                  <a:srgbClr val="000000"/>
+                </a:solidFill>
+                <a:latin typeface="Arial"/>
+              </a:rPr>
+              <a:t>¿Cómo controlamos el inventario?</a:t>
             </a:r>
           </a:p>
         </p:txBody>
@@ -3945,7 +4093,7 @@
         </p:nvCxnSpPr>
         <p:spPr>
           <a:xfrm>
-            <a:off x="640080" y="1261872"/>
+            <a:off x="640080" y="1170432"/>
             <a:ext cx="4754880" cy="0"/>
           </a:xfrm>
           <a:prstGeom prst="line">
@@ -3980,8 +4128,8 @@
         </p:nvSpPr>
         <p:spPr>
           <a:xfrm>
-            <a:off x="640080" y="1554480"/>
-            <a:ext cx="10911535" cy="4754880"/>
+            <a:off x="640080" y="1371600"/>
+            <a:ext cx="10911535" cy="2926080"/>
           </a:xfrm>
           <a:prstGeom prst="rect">
             <a:avLst/>
@@ -3996,11 +4144,11 @@
           <a:p>
             <a:pPr>
               <a:spcAft>
-                <a:spcPts val="800"/>
+                <a:spcPts val="400"/>
               </a:spcAft>
             </a:pPr>
             <a:r>
-              <a:rPr sz="2000">
+              <a:rPr sz="1700">
                 <a:solidFill>
                   <a:srgbClr val="000000"/>
                 </a:solidFill>
@@ -4009,32 +4157,32 @@
               <a:t>– </a:t>
             </a:r>
             <a:r>
-              <a:rPr b="1" sz="2000">
-                <a:solidFill>
-                  <a:srgbClr val="000000"/>
-                </a:solidFill>
-                <a:latin typeface="Arial"/>
-              </a:rPr>
-              <a:t>SP1 — Registrar consulta y emitir receta.</a:t>
-            </a:r>
-            <a:r>
-              <a:rPr sz="2000">
-                <a:solidFill>
-                  <a:srgbClr val="000000"/>
-                </a:solidFill>
-                <a:latin typeface="Arial"/>
-              </a:rPr>
-              <a:t> Valida paciente activo, médico con cédula vigente y alergias; inserta consulta, receta y detalle.</a:t>
+              <a:rPr b="1" sz="1700">
+                <a:solidFill>
+                  <a:srgbClr val="000000"/>
+                </a:solidFill>
+                <a:latin typeface="Arial"/>
+              </a:rPr>
+              <a:t>Stock de medicamentos:</a:t>
+            </a:r>
+            <a:r>
+              <a:rPr sz="1700">
+                <a:solidFill>
+                  <a:srgbClr val="000000"/>
+                </a:solidFill>
+                <a:latin typeface="Arial"/>
+              </a:rPr>
+              <a:t> estado suficiente / bajo / crítico / agotado.</a:t>
             </a:r>
           </a:p>
           <a:p>
             <a:pPr>
               <a:spcAft>
-                <a:spcPts val="800"/>
+                <a:spcPts val="400"/>
               </a:spcAft>
             </a:pPr>
             <a:r>
-              <a:rPr sz="2000">
+              <a:rPr sz="1700">
                 <a:solidFill>
                   <a:srgbClr val="000000"/>
                 </a:solidFill>
@@ -4043,32 +4191,32 @@
               <a:t>– </a:t>
             </a:r>
             <a:r>
-              <a:rPr b="1" sz="2000">
-                <a:solidFill>
-                  <a:srgbClr val="000000"/>
-                </a:solidFill>
-                <a:latin typeface="Arial"/>
-              </a:rPr>
-              <a:t>SP2 — Surtir receta y actualizar inventario.</a:t>
-            </a:r>
-            <a:r>
-              <a:rPr sz="2000">
-                <a:solidFill>
-                  <a:srgbClr val="000000"/>
-                </a:solidFill>
-                <a:latin typeface="Arial"/>
-              </a:rPr>
-              <a:t> Verifica vigencia, asigna lote no vencido, registra la venta y descuenta stock automáticamente.</a:t>
+              <a:rPr b="1" sz="1700">
+                <a:solidFill>
+                  <a:srgbClr val="000000"/>
+                </a:solidFill>
+                <a:latin typeface="Arial"/>
+              </a:rPr>
+              <a:t>Lotes y caducidades:</a:t>
+            </a:r>
+            <a:r>
+              <a:rPr sz="1700">
+                <a:solidFill>
+                  <a:srgbClr val="000000"/>
+                </a:solidFill>
+                <a:latin typeface="Arial"/>
+              </a:rPr>
+              <a:t> se dispensa el lote no vencido más próximo a caducar.</a:t>
             </a:r>
           </a:p>
           <a:p>
             <a:pPr>
               <a:spcAft>
-                <a:spcPts val="800"/>
+                <a:spcPts val="400"/>
               </a:spcAft>
             </a:pPr>
             <a:r>
-              <a:rPr sz="2000">
+              <a:rPr sz="1700">
                 <a:solidFill>
                   <a:srgbClr val="000000"/>
                 </a:solidFill>
@@ -4077,29 +4225,117 @@
               <a:t>– </a:t>
             </a:r>
             <a:r>
-              <a:rPr b="1" sz="2000">
-                <a:solidFill>
-                  <a:srgbClr val="000000"/>
-                </a:solidFill>
-                <a:latin typeface="Arial"/>
-              </a:rPr>
-              <a:t>SP3 — Generar órdenes de reposición por stock mínimo.</a:t>
-            </a:r>
-            <a:r>
-              <a:rPr sz="2000">
-                <a:solidFill>
-                  <a:srgbClr val="000000"/>
-                </a:solidFill>
-                <a:latin typeface="Arial"/>
-              </a:rPr>
-              <a:t> Evalúa stock ≤ mínimo y crea la orden sin duplicados.</a:t>
-            </a:r>
-          </a:p>
-        </p:txBody>
-      </p:sp>
-      <p:sp>
-        <p:nvSpPr>
-          <p:cNvPr id="5" name="TextBox 4"/>
+              <a:rPr b="1" sz="1700">
+                <a:solidFill>
+                  <a:srgbClr val="000000"/>
+                </a:solidFill>
+                <a:latin typeface="Arial"/>
+              </a:rPr>
+              <a:t>Reposición:</a:t>
+            </a:r>
+            <a:r>
+              <a:rPr sz="1700">
+                <a:solidFill>
+                  <a:srgbClr val="000000"/>
+                </a:solidFill>
+                <a:latin typeface="Arial"/>
+              </a:rPr>
+              <a:t> órdenes automáticas al llegar al stock mínimo.</a:t>
+            </a:r>
+          </a:p>
+          <a:p>
+            <a:pPr>
+              <a:spcAft>
+                <a:spcPts val="400"/>
+              </a:spcAft>
+            </a:pPr>
+            <a:r>
+              <a:rPr sz="1700">
+                <a:solidFill>
+                  <a:srgbClr val="000000"/>
+                </a:solidFill>
+                <a:latin typeface="Arial"/>
+              </a:rPr>
+              <a:t>– </a:t>
+            </a:r>
+            <a:r>
+              <a:rPr b="1" sz="1700">
+                <a:solidFill>
+                  <a:srgbClr val="000000"/>
+                </a:solidFill>
+                <a:latin typeface="Arial"/>
+              </a:rPr>
+              <a:t>Auditoría de movimientos:</a:t>
+            </a:r>
+            <a:r>
+              <a:rPr sz="1700">
+                <a:solidFill>
+                  <a:srgbClr val="000000"/>
+                </a:solidFill>
+                <a:latin typeface="Arial"/>
+              </a:rPr>
+              <a:t> cada cambio de stock queda registrado.</a:t>
+            </a:r>
+          </a:p>
+        </p:txBody>
+      </p:sp>
+      <p:sp>
+        <p:nvSpPr>
+          <p:cNvPr id="5" name="Rectangle 4"/>
+          <p:cNvSpPr/>
+          <p:nvPr/>
+        </p:nvSpPr>
+        <p:spPr>
+          <a:xfrm>
+            <a:off x="1981047" y="4572000"/>
+            <a:ext cx="8229600" cy="1554480"/>
+          </a:xfrm>
+          <a:prstGeom prst="rect">
+            <a:avLst/>
+          </a:prstGeom>
+          <a:solidFill>
+            <a:srgbClr val="FFFFFF"/>
+          </a:solidFill>
+          <a:ln w="12700">
+            <a:solidFill>
+              <a:srgbClr val="000000"/>
+            </a:solidFill>
+          </a:ln>
+        </p:spPr>
+        <p:style>
+          <a:lnRef idx="1">
+            <a:schemeClr val="accent1"/>
+          </a:lnRef>
+          <a:fillRef idx="3">
+            <a:schemeClr val="accent1"/>
+          </a:fillRef>
+          <a:effectRef idx="2">
+            <a:schemeClr val="accent1"/>
+          </a:effectRef>
+          <a:fontRef idx="minor">
+            <a:schemeClr val="lt1"/>
+          </a:fontRef>
+        </p:style>
+        <p:txBody>
+          <a:bodyPr rtlCol="0" anchor="ctr" wrap="square"/>
+          <a:lstStyle/>
+          <a:p>
+            <a:pPr algn="ctr"/>
+            <a:r>
+              <a:rPr i="1" sz="1500">
+                <a:solidFill>
+                  <a:srgbClr val="404040"/>
+                </a:solidFill>
+                <a:latin typeface="Arial"/>
+              </a:rPr>
+              <a:t>[Evidencia: inventario + LOG de auditoría]</a:t>
+            </a:r>
+          </a:p>
+        </p:txBody>
+      </p:sp>
+      <p:sp>
+        <p:nvSpPr>
+          <p:cNvPr id="6" name="TextBox 5"/>
           <p:cNvSpPr txBox="1"/>
           <p:nvPr/>
         </p:nvSpPr>
@@ -4133,7 +4369,7 @@
       </p:sp>
       <p:sp>
         <p:nvSpPr>
-          <p:cNvPr id="6" name="TextBox 5"/>
+          <p:cNvPr id="7" name="TextBox 6"/>
           <p:cNvSpPr txBox="1"/>
           <p:nvPr/>
         </p:nvSpPr>
@@ -4200,7 +4436,7 @@
         </p:nvSpPr>
         <p:spPr>
           <a:xfrm>
-            <a:off x="640080" y="411480"/>
+            <a:off x="640080" y="365760"/>
             <a:ext cx="10911535" cy="822960"/>
           </a:xfrm>
           <a:prstGeom prst="rect">
@@ -4215,13 +4451,13 @@
           <a:lstStyle/>
           <a:p>
             <a:r>
-              <a:rPr sz="3000" b="1">
-                <a:solidFill>
-                  <a:srgbClr val="000000"/>
-                </a:solidFill>
-                <a:latin typeface="Arial"/>
-              </a:rPr>
-              <a:t>Automatización y trazabilidad: Triggers y LOG</a:t>
+              <a:rPr sz="2800" b="1">
+                <a:solidFill>
+                  <a:srgbClr val="000000"/>
+                </a:solidFill>
+                <a:latin typeface="Arial"/>
+              </a:rPr>
+              <a:t>¿Cómo integramos operación y tecnología?</a:t>
             </a:r>
           </a:p>
         </p:txBody>
@@ -4234,7 +4470,7 @@
         </p:nvCxnSpPr>
         <p:spPr>
           <a:xfrm>
-            <a:off x="640080" y="1261872"/>
+            <a:off x="640080" y="1170432"/>
             <a:ext cx="4754880" cy="0"/>
           </a:xfrm>
           <a:prstGeom prst="line">
@@ -4269,8 +4505,8 @@
         </p:nvSpPr>
         <p:spPr>
           <a:xfrm>
-            <a:off x="640080" y="1554480"/>
-            <a:ext cx="10911535" cy="3108960"/>
+            <a:off x="640080" y="1371600"/>
+            <a:ext cx="10911535" cy="2926080"/>
           </a:xfrm>
           <a:prstGeom prst="rect">
             <a:avLst/>
@@ -4285,11 +4521,11 @@
           <a:p>
             <a:pPr>
               <a:spcAft>
-                <a:spcPts val="800"/>
+                <a:spcPts val="400"/>
               </a:spcAft>
             </a:pPr>
             <a:r>
-              <a:rPr sz="2000">
+              <a:rPr sz="1700">
                 <a:solidFill>
                   <a:srgbClr val="000000"/>
                 </a:solidFill>
@@ -4298,32 +4534,32 @@
               <a:t>– </a:t>
             </a:r>
             <a:r>
-              <a:rPr b="1" sz="2000">
-                <a:solidFill>
-                  <a:srgbClr val="000000"/>
-                </a:solidFill>
-                <a:latin typeface="Arial"/>
-              </a:rPr>
-              <a:t>Trigger 1 — BEFORE INSERT en Detalles_Receta.</a:t>
-            </a:r>
-            <a:r>
-              <a:rPr sz="2000">
-                <a:solidFill>
-                  <a:srgbClr val="000000"/>
-                </a:solidFill>
-                <a:latin typeface="Arial"/>
-              </a:rPr>
-              <a:t> Bloquea recetas con contraindicaciones, interacciones o datos inválidos.</a:t>
+              <a:rPr b="1" sz="1700">
+                <a:solidFill>
+                  <a:srgbClr val="000000"/>
+                </a:solidFill>
+                <a:latin typeface="Arial"/>
+              </a:rPr>
+              <a:t>Proceso operativo:</a:t>
+            </a:r>
+            <a:r>
+              <a:rPr sz="1700">
+                <a:solidFill>
+                  <a:srgbClr val="000000"/>
+                </a:solidFill>
+                <a:latin typeface="Arial"/>
+              </a:rPr>
+              <a:t> el flujo real del negocio, estandarizado.</a:t>
             </a:r>
           </a:p>
           <a:p>
             <a:pPr>
               <a:spcAft>
-                <a:spcPts val="800"/>
+                <a:spcPts val="400"/>
               </a:spcAft>
             </a:pPr>
             <a:r>
-              <a:rPr sz="2000">
+              <a:rPr sz="1700">
                 <a:solidFill>
                   <a:srgbClr val="000000"/>
                 </a:solidFill>
@@ -4332,56 +4568,144 @@
               <a:t>– </a:t>
             </a:r>
             <a:r>
-              <a:rPr b="1" sz="2000">
-                <a:solidFill>
-                  <a:srgbClr val="000000"/>
-                </a:solidFill>
-                <a:latin typeface="Arial"/>
-              </a:rPr>
-              <a:t>Trigger 2 — AFTER UPDATE en Inventario.</a:t>
-            </a:r>
-            <a:r>
-              <a:rPr sz="2000">
-                <a:solidFill>
-                  <a:srgbClr val="000000"/>
-                </a:solidFill>
-                <a:latin typeface="Arial"/>
-              </a:rPr>
-              <a:t> Registra cada movimiento de stock en la tabla LOG Auditoria_Inventario para trazabilidad total.</a:t>
-            </a:r>
-          </a:p>
-        </p:txBody>
-      </p:sp>
-      <p:sp>
-        <p:nvSpPr>
-          <p:cNvPr id="5" name="TextBox 4"/>
-          <p:cNvSpPr txBox="1"/>
+              <a:rPr b="1" sz="1700">
+                <a:solidFill>
+                  <a:srgbClr val="000000"/>
+                </a:solidFill>
+                <a:latin typeface="Arial"/>
+              </a:rPr>
+              <a:t>Reglas de negocio:</a:t>
+            </a:r>
+            <a:r>
+              <a:rPr sz="1700">
+                <a:solidFill>
+                  <a:srgbClr val="000000"/>
+                </a:solidFill>
+                <a:latin typeface="Arial"/>
+              </a:rPr>
+              <a:t> llevadas a restricciones, SP y triggers.</a:t>
+            </a:r>
+          </a:p>
+          <a:p>
+            <a:pPr>
+              <a:spcAft>
+                <a:spcPts val="400"/>
+              </a:spcAft>
+            </a:pPr>
+            <a:r>
+              <a:rPr sz="1700">
+                <a:solidFill>
+                  <a:srgbClr val="000000"/>
+                </a:solidFill>
+                <a:latin typeface="Arial"/>
+              </a:rPr>
+              <a:t>– </a:t>
+            </a:r>
+            <a:r>
+              <a:rPr b="1" sz="1700">
+                <a:solidFill>
+                  <a:srgbClr val="000000"/>
+                </a:solidFill>
+                <a:latin typeface="Arial"/>
+              </a:rPr>
+              <a:t>Base de datos:</a:t>
+            </a:r>
+            <a:r>
+              <a:rPr sz="1700">
+                <a:solidFill>
+                  <a:srgbClr val="000000"/>
+                </a:solidFill>
+                <a:latin typeface="Arial"/>
+              </a:rPr>
+              <a:t> MySQL como fuente única de verdad.</a:t>
+            </a:r>
+          </a:p>
+          <a:p>
+            <a:pPr>
+              <a:spcAft>
+                <a:spcPts val="400"/>
+              </a:spcAft>
+            </a:pPr>
+            <a:r>
+              <a:rPr sz="1700">
+                <a:solidFill>
+                  <a:srgbClr val="000000"/>
+                </a:solidFill>
+                <a:latin typeface="Arial"/>
+              </a:rPr>
+              <a:t>– </a:t>
+            </a:r>
+            <a:r>
+              <a:rPr b="1" sz="1700">
+                <a:solidFill>
+                  <a:srgbClr val="000000"/>
+                </a:solidFill>
+                <a:latin typeface="Arial"/>
+              </a:rPr>
+              <a:t>Conexión Java–MySQL:</a:t>
+            </a:r>
+            <a:r>
+              <a:rPr sz="1700">
+                <a:solidFill>
+                  <a:srgbClr val="000000"/>
+                </a:solidFill>
+                <a:latin typeface="Arial"/>
+              </a:rPr>
+              <a:t> acceso a los datos desde la aplicación (JDBC).</a:t>
+            </a:r>
+          </a:p>
+        </p:txBody>
+      </p:sp>
+      <p:sp>
+        <p:nvSpPr>
+          <p:cNvPr id="5" name="Rectangle 4"/>
+          <p:cNvSpPr/>
           <p:nvPr/>
         </p:nvSpPr>
         <p:spPr>
           <a:xfrm>
-            <a:off x="640080" y="4937760"/>
-            <a:ext cx="10911535" cy="457200"/>
+            <a:off x="1981047" y="4572000"/>
+            <a:ext cx="8229600" cy="1554480"/>
           </a:xfrm>
           <a:prstGeom prst="rect">
             <a:avLst/>
           </a:prstGeom>
-          <a:noFill/>
-        </p:spPr>
-        <p:txBody>
-          <a:bodyPr wrap="square">
-            <a:spAutoFit/>
-          </a:bodyPr>
-          <a:lstStyle/>
-          <a:p>
-            <a:r>
-              <a:rPr b="0" sz="1500">
-                <a:solidFill>
-                  <a:srgbClr val="000000"/>
-                </a:solidFill>
-                <a:latin typeface="Arial"/>
-              </a:rPr>
-              <a:t>La automatización aplica las reglas de negocio sin intervención manual.</a:t>
+          <a:solidFill>
+            <a:srgbClr val="FFFFFF"/>
+          </a:solidFill>
+          <a:ln w="12700">
+            <a:solidFill>
+              <a:srgbClr val="000000"/>
+            </a:solidFill>
+          </a:ln>
+        </p:spPr>
+        <p:style>
+          <a:lnRef idx="1">
+            <a:schemeClr val="accent1"/>
+          </a:lnRef>
+          <a:fillRef idx="3">
+            <a:schemeClr val="accent1"/>
+          </a:fillRef>
+          <a:effectRef idx="2">
+            <a:schemeClr val="accent1"/>
+          </a:effectRef>
+          <a:fontRef idx="minor">
+            <a:schemeClr val="lt1"/>
+          </a:fontRef>
+        </p:style>
+        <p:txBody>
+          <a:bodyPr rtlCol="0" anchor="ctr" wrap="square"/>
+          <a:lstStyle/>
+          <a:p>
+            <a:pPr algn="ctr"/>
+            <a:r>
+              <a:rPr i="1" sz="1500">
+                <a:solidFill>
+                  <a:srgbClr val="404040"/>
+                </a:solidFill>
+                <a:latin typeface="Arial"/>
+              </a:rPr>
+              <a:t>[Evidencia: conexión y consulta desde Java (App.java)]</a:t>
             </a:r>
           </a:p>
         </p:txBody>
@@ -4489,7 +4813,7 @@
         </p:nvSpPr>
         <p:spPr>
           <a:xfrm>
-            <a:off x="640080" y="411480"/>
+            <a:off x="640080" y="365760"/>
             <a:ext cx="10911535" cy="822960"/>
           </a:xfrm>
           <a:prstGeom prst="rect">
@@ -4504,13 +4828,13 @@
           <a:lstStyle/>
           <a:p>
             <a:r>
-              <a:rPr sz="3000" b="1">
-                <a:solidFill>
-                  <a:srgbClr val="000000"/>
-                </a:solidFill>
-                <a:latin typeface="Arial"/>
-              </a:rPr>
-              <a:t>Los datos en uso: conexión Java (JDBC)</a:t>
+              <a:rPr sz="2800" b="1">
+                <a:solidFill>
+                  <a:srgbClr val="000000"/>
+                </a:solidFill>
+                <a:latin typeface="Arial"/>
+              </a:rPr>
+              <a:t>¿Por qué es importante una estrategia integral?</a:t>
             </a:r>
           </a:p>
         </p:txBody>
@@ -4523,7 +4847,7 @@
         </p:nvCxnSpPr>
         <p:spPr>
           <a:xfrm>
-            <a:off x="640080" y="1261872"/>
+            <a:off x="640080" y="1170432"/>
             <a:ext cx="4754880" cy="0"/>
           </a:xfrm>
           <a:prstGeom prst="line">
@@ -4558,8 +4882,8 @@
         </p:nvSpPr>
         <p:spPr>
           <a:xfrm>
-            <a:off x="640080" y="1554480"/>
-            <a:ext cx="10911535" cy="1645920"/>
+            <a:off x="640080" y="1463040"/>
+            <a:ext cx="10911535" cy="3291840"/>
           </a:xfrm>
           <a:prstGeom prst="rect">
             <a:avLst/>
@@ -4574,103 +4898,171 @@
           <a:p>
             <a:pPr>
               <a:spcAft>
-                <a:spcPts val="800"/>
+                <a:spcPts val="400"/>
               </a:spcAft>
             </a:pPr>
             <a:r>
-              <a:rPr sz="2000">
-                <a:solidFill>
-                  <a:srgbClr val="000000"/>
-                </a:solidFill>
-                <a:latin typeface="Arial"/>
-              </a:rPr>
-              <a:t>– App.java conecta a MySQL (instancia gestionada en Aiven, SSL).</a:t>
+              <a:rPr sz="1900">
+                <a:solidFill>
+                  <a:srgbClr val="000000"/>
+                </a:solidFill>
+                <a:latin typeface="Arial"/>
+              </a:rPr>
+              <a:t>– </a:t>
+            </a:r>
+            <a:r>
+              <a:rPr b="1" sz="1900">
+                <a:solidFill>
+                  <a:srgbClr val="000000"/>
+                </a:solidFill>
+                <a:latin typeface="Arial"/>
+              </a:rPr>
+              <a:t>Entender las reglas de negocio:</a:t>
+            </a:r>
+            <a:r>
+              <a:rPr sz="1900">
+                <a:solidFill>
+                  <a:srgbClr val="000000"/>
+                </a:solidFill>
+                <a:latin typeface="Arial"/>
+              </a:rPr>
+              <a:t> define qué debe validar el sistema.</a:t>
             </a:r>
           </a:p>
           <a:p>
             <a:pPr>
               <a:spcAft>
-                <a:spcPts val="800"/>
+                <a:spcPts val="400"/>
               </a:spcAft>
             </a:pPr>
             <a:r>
-              <a:rPr sz="2000">
-                <a:solidFill>
-                  <a:srgbClr val="000000"/>
-                </a:solidFill>
-                <a:latin typeface="Arial"/>
-              </a:rPr>
-              <a:t>– Credenciales fuera del código (variables de entorno seguras).</a:t>
+              <a:rPr sz="1900">
+                <a:solidFill>
+                  <a:srgbClr val="000000"/>
+                </a:solidFill>
+                <a:latin typeface="Arial"/>
+              </a:rPr>
+              <a:t>– </a:t>
+            </a:r>
+            <a:r>
+              <a:rPr b="1" sz="1900">
+                <a:solidFill>
+                  <a:srgbClr val="000000"/>
+                </a:solidFill>
+                <a:latin typeface="Arial"/>
+              </a:rPr>
+              <a:t>Mapear correctamente el flujo de información:</a:t>
+            </a:r>
+            <a:r>
+              <a:rPr sz="1900">
+                <a:solidFill>
+                  <a:srgbClr val="000000"/>
+                </a:solidFill>
+                <a:latin typeface="Arial"/>
+              </a:rPr>
+              <a:t> evita islas de datos.</a:t>
             </a:r>
           </a:p>
           <a:p>
             <a:pPr>
               <a:spcAft>
-                <a:spcPts val="800"/>
+                <a:spcPts val="400"/>
               </a:spcAft>
             </a:pPr>
             <a:r>
-              <a:rPr sz="2000">
-                <a:solidFill>
-                  <a:srgbClr val="000000"/>
-                </a:solidFill>
-                <a:latin typeface="Arial"/>
-              </a:rPr>
-              <a:t>– Consulta Pacientes y despliega el Dataset resultante.</a:t>
-            </a:r>
-          </a:p>
-        </p:txBody>
-      </p:sp>
-      <p:sp>
-        <p:nvSpPr>
-          <p:cNvPr id="5" name="Rectangle 4"/>
-          <p:cNvSpPr/>
+              <a:rPr sz="1900">
+                <a:solidFill>
+                  <a:srgbClr val="000000"/>
+                </a:solidFill>
+                <a:latin typeface="Arial"/>
+              </a:rPr>
+              <a:t>– </a:t>
+            </a:r>
+            <a:r>
+              <a:rPr b="1" sz="1900">
+                <a:solidFill>
+                  <a:srgbClr val="000000"/>
+                </a:solidFill>
+                <a:latin typeface="Arial"/>
+              </a:rPr>
+              <a:t>Integrar operación y tecnología:</a:t>
+            </a:r>
+            <a:r>
+              <a:rPr sz="1900">
+                <a:solidFill>
+                  <a:srgbClr val="000000"/>
+                </a:solidFill>
+                <a:latin typeface="Arial"/>
+              </a:rPr>
+              <a:t> una sola fuente de verdad.</a:t>
+            </a:r>
+          </a:p>
+          <a:p>
+            <a:pPr>
+              <a:spcAft>
+                <a:spcPts val="400"/>
+              </a:spcAft>
+            </a:pPr>
+            <a:r>
+              <a:rPr sz="1900">
+                <a:solidFill>
+                  <a:srgbClr val="000000"/>
+                </a:solidFill>
+                <a:latin typeface="Arial"/>
+              </a:rPr>
+              <a:t>– </a:t>
+            </a:r>
+            <a:r>
+              <a:rPr b="1" sz="1900">
+                <a:solidFill>
+                  <a:srgbClr val="000000"/>
+                </a:solidFill>
+                <a:latin typeface="Arial"/>
+              </a:rPr>
+              <a:t>Gestionar la correcta ejecución:</a:t>
+            </a:r>
+            <a:r>
+              <a:rPr sz="1900">
+                <a:solidFill>
+                  <a:srgbClr val="000000"/>
+                </a:solidFill>
+                <a:latin typeface="Arial"/>
+              </a:rPr>
+              <a:t> vistas, SP y triggers hacen cumplir las reglas.</a:t>
+            </a:r>
+          </a:p>
+        </p:txBody>
+      </p:sp>
+      <p:sp>
+        <p:nvSpPr>
+          <p:cNvPr id="5" name="TextBox 4"/>
+          <p:cNvSpPr txBox="1"/>
           <p:nvPr/>
         </p:nvSpPr>
         <p:spPr>
           <a:xfrm>
-            <a:off x="1752447" y="3291840"/>
-            <a:ext cx="8686800" cy="2377440"/>
+            <a:off x="640080" y="4937760"/>
+            <a:ext cx="10911535" cy="457200"/>
           </a:xfrm>
           <a:prstGeom prst="rect">
             <a:avLst/>
           </a:prstGeom>
-          <a:solidFill>
-            <a:srgbClr val="FFFFFF"/>
-          </a:solidFill>
-          <a:ln w="12700">
-            <a:solidFill>
-              <a:srgbClr val="000000"/>
-            </a:solidFill>
-          </a:ln>
-        </p:spPr>
-        <p:style>
-          <a:lnRef idx="1">
-            <a:schemeClr val="accent1"/>
-          </a:lnRef>
-          <a:fillRef idx="3">
-            <a:schemeClr val="accent1"/>
-          </a:fillRef>
-          <a:effectRef idx="2">
-            <a:schemeClr val="accent1"/>
-          </a:effectRef>
-          <a:fontRef idx="minor">
-            <a:schemeClr val="lt1"/>
-          </a:fontRef>
-        </p:style>
-        <p:txBody>
-          <a:bodyPr rtlCol="0" anchor="ctr" wrap="square"/>
-          <a:lstStyle/>
-          <a:p>
-            <a:pPr algn="ctr"/>
-            <a:r>
-              <a:rPr i="1" sz="1600">
+          <a:noFill/>
+        </p:spPr>
+        <p:txBody>
+          <a:bodyPr wrap="none">
+            <a:spAutoFit/>
+          </a:bodyPr>
+          <a:lstStyle/>
+          <a:p>
+            <a:r>
+              <a:rPr i="1" sz="1400">
                 <a:solidFill>
                   <a:srgbClr val="404040"/>
                 </a:solidFill>
                 <a:latin typeface="Arial"/>
               </a:rPr>
-              <a:t>[Captura de pantalla: salida de la ejecución de App.java]</a:t>
+              <a:t>Responde directamente a los cuatro puntos de la exposición oral.</a:t>
             </a:r>
           </a:p>
         </p:txBody>
@@ -4778,7 +5170,7 @@
         </p:nvSpPr>
         <p:spPr>
           <a:xfrm>
-            <a:off x="640080" y="411480"/>
+            <a:off x="640080" y="365760"/>
             <a:ext cx="10911535" cy="822960"/>
           </a:xfrm>
           <a:prstGeom prst="rect">
@@ -4793,13 +5185,13 @@
           <a:lstStyle/>
           <a:p>
             <a:r>
-              <a:rPr sz="3000" b="1">
-                <a:solidFill>
-                  <a:srgbClr val="000000"/>
-                </a:solidFill>
-                <a:latin typeface="Arial"/>
-              </a:rPr>
-              <a:t>Validación: 3 ejemplos de SP y Triggers</a:t>
+              <a:rPr sz="2800" b="1">
+                <a:solidFill>
+                  <a:srgbClr val="000000"/>
+                </a:solidFill>
+                <a:latin typeface="Arial"/>
+              </a:rPr>
+              <a:t>¿Qué beneficios obtenemos?</a:t>
             </a:r>
           </a:p>
         </p:txBody>
@@ -4812,7 +5204,7 @@
         </p:nvCxnSpPr>
         <p:spPr>
           <a:xfrm>
-            <a:off x="640080" y="1261872"/>
+            <a:off x="640080" y="1170432"/>
             <a:ext cx="4754880" cy="0"/>
           </a:xfrm>
           <a:prstGeom prst="line">
@@ -4847,8 +5239,8 @@
         </p:nvSpPr>
         <p:spPr>
           <a:xfrm>
-            <a:off x="640080" y="1554480"/>
-            <a:ext cx="10911535" cy="2377440"/>
+            <a:off x="640080" y="1463040"/>
+            <a:ext cx="10911535" cy="4206240"/>
           </a:xfrm>
           <a:prstGeom prst="rect">
             <a:avLst/>
@@ -4863,7 +5255,7 @@
           <a:p>
             <a:pPr>
               <a:spcAft>
-                <a:spcPts val="800"/>
+                <a:spcPts val="400"/>
               </a:spcAft>
             </a:pPr>
             <a:r>
@@ -4873,16 +5265,16 @@
                 </a:solidFill>
                 <a:latin typeface="Arial"/>
               </a:rPr>
-              <a:t>1.  </a:t>
-            </a:r>
-            <a:r>
-              <a:rPr sz="1900" b="1">
-                <a:solidFill>
-                  <a:srgbClr val="000000"/>
-                </a:solidFill>
-                <a:latin typeface="Arial"/>
-              </a:rPr>
-              <a:t>SP1:</a:t>
+              <a:t>– </a:t>
+            </a:r>
+            <a:r>
+              <a:rPr b="1" sz="1900">
+                <a:solidFill>
+                  <a:srgbClr val="000000"/>
+                </a:solidFill>
+                <a:latin typeface="Arial"/>
+              </a:rPr>
+              <a:t>Seguridad del paciente:</a:t>
             </a:r>
             <a:r>
               <a:rPr sz="1900">
@@ -4891,13 +5283,13 @@
                 </a:solidFill>
                 <a:latin typeface="Arial"/>
               </a:rPr>
-              <a:t> receta a paciente con alergia ⇒ el sistema la rechaza con mensaje de riesgo clínico.</a:t>
+              <a:t> validaciones clínicas automáticas.</a:t>
             </a:r>
           </a:p>
           <a:p>
             <a:pPr>
               <a:spcAft>
-                <a:spcPts val="800"/>
+                <a:spcPts val="400"/>
               </a:spcAft>
             </a:pPr>
             <a:r>
@@ -4907,16 +5299,16 @@
                 </a:solidFill>
                 <a:latin typeface="Arial"/>
               </a:rPr>
-              <a:t>2.  </a:t>
-            </a:r>
-            <a:r>
-              <a:rPr sz="1900" b="1">
-                <a:solidFill>
-                  <a:srgbClr val="000000"/>
-                </a:solidFill>
-                <a:latin typeface="Arial"/>
-              </a:rPr>
-              <a:t>SP2:</a:t>
+              <a:t>– </a:t>
+            </a:r>
+            <a:r>
+              <a:rPr b="1" sz="1900">
+                <a:solidFill>
+                  <a:srgbClr val="000000"/>
+                </a:solidFill>
+                <a:latin typeface="Arial"/>
+              </a:rPr>
+              <a:t>Eficiencia operativa:</a:t>
             </a:r>
             <a:r>
               <a:rPr sz="1900">
@@ -4925,13 +5317,13 @@
                 </a:solidFill>
                 <a:latin typeface="Arial"/>
               </a:rPr>
-              <a:t> surtir receta vigente ⇒ se registra la venta y disminuye el stock.</a:t>
+              <a:t> procesos estandarizados y más rápidos.</a:t>
             </a:r>
           </a:p>
           <a:p>
             <a:pPr>
               <a:spcAft>
-                <a:spcPts val="800"/>
+                <a:spcPts val="400"/>
               </a:spcAft>
             </a:pPr>
             <a:r>
@@ -4941,16 +5333,16 @@
                 </a:solidFill>
                 <a:latin typeface="Arial"/>
               </a:rPr>
-              <a:t>3.  </a:t>
-            </a:r>
-            <a:r>
-              <a:rPr sz="1900" b="1">
-                <a:solidFill>
-                  <a:srgbClr val="000000"/>
-                </a:solidFill>
-                <a:latin typeface="Arial"/>
-              </a:rPr>
-              <a:t>Trigger 2:</a:t>
+              <a:t>– </a:t>
+            </a:r>
+            <a:r>
+              <a:rPr b="1" sz="1900">
+                <a:solidFill>
+                  <a:srgbClr val="000000"/>
+                </a:solidFill>
+                <a:latin typeface="Arial"/>
+              </a:rPr>
+              <a:t>Control del inventario:</a:t>
             </a:r>
             <a:r>
               <a:rPr sz="1900">
@@ -4959,68 +5351,82 @@
                 </a:solidFill>
                 <a:latin typeface="Arial"/>
               </a:rPr>
-              <a:t> tras el surtido ⇒ registro automático en Auditoria_Inventario.</a:t>
-            </a:r>
-          </a:p>
-        </p:txBody>
-      </p:sp>
-      <p:sp>
-        <p:nvSpPr>
-          <p:cNvPr id="5" name="Rectangle 4"/>
-          <p:cNvSpPr/>
-          <p:nvPr/>
-        </p:nvSpPr>
-        <p:spPr>
-          <a:xfrm>
-            <a:off x="1752447" y="4023360"/>
-            <a:ext cx="8686800" cy="2194560"/>
-          </a:xfrm>
-          <a:prstGeom prst="rect">
-            <a:avLst/>
-          </a:prstGeom>
-          <a:solidFill>
-            <a:srgbClr val="FFFFFF"/>
-          </a:solidFill>
-          <a:ln w="12700">
-            <a:solidFill>
-              <a:srgbClr val="000000"/>
-            </a:solidFill>
-          </a:ln>
-        </p:spPr>
-        <p:style>
-          <a:lnRef idx="1">
-            <a:schemeClr val="accent1"/>
-          </a:lnRef>
-          <a:fillRef idx="3">
-            <a:schemeClr val="accent1"/>
-          </a:fillRef>
-          <a:effectRef idx="2">
-            <a:schemeClr val="accent1"/>
-          </a:effectRef>
-          <a:fontRef idx="minor">
-            <a:schemeClr val="lt1"/>
-          </a:fontRef>
-        </p:style>
-        <p:txBody>
-          <a:bodyPr rtlCol="0" anchor="ctr" wrap="square"/>
-          <a:lstStyle/>
-          <a:p>
-            <a:pPr algn="ctr"/>
-            <a:r>
-              <a:rPr i="1" sz="1600">
-                <a:solidFill>
-                  <a:srgbClr val="404040"/>
-                </a:solidFill>
-                <a:latin typeface="Arial"/>
-              </a:rPr>
-              <a:t>[Captura de pantalla: ejecución de los 3 ejemplos con su resultado]</a:t>
-            </a:r>
-          </a:p>
-        </p:txBody>
-      </p:sp>
-      <p:sp>
-        <p:nvSpPr>
-          <p:cNvPr id="6" name="TextBox 5"/>
+              <a:t> menos desabasto y menos mermas.</a:t>
+            </a:r>
+          </a:p>
+          <a:p>
+            <a:pPr>
+              <a:spcAft>
+                <a:spcPts val="400"/>
+              </a:spcAft>
+            </a:pPr>
+            <a:r>
+              <a:rPr sz="1900">
+                <a:solidFill>
+                  <a:srgbClr val="000000"/>
+                </a:solidFill>
+                <a:latin typeface="Arial"/>
+              </a:rPr>
+              <a:t>– </a:t>
+            </a:r>
+            <a:r>
+              <a:rPr b="1" sz="1900">
+                <a:solidFill>
+                  <a:srgbClr val="000000"/>
+                </a:solidFill>
+                <a:latin typeface="Arial"/>
+              </a:rPr>
+              <a:t>Automatización:</a:t>
+            </a:r>
+            <a:r>
+              <a:rPr sz="1900">
+                <a:solidFill>
+                  <a:srgbClr val="000000"/>
+                </a:solidFill>
+                <a:latin typeface="Arial"/>
+              </a:rPr>
+              <a:t> menos errores manuales.</a:t>
+            </a:r>
+          </a:p>
+          <a:p>
+            <a:pPr>
+              <a:spcAft>
+                <a:spcPts val="400"/>
+              </a:spcAft>
+            </a:pPr>
+            <a:r>
+              <a:rPr sz="1900">
+                <a:solidFill>
+                  <a:srgbClr val="000000"/>
+                </a:solidFill>
+                <a:latin typeface="Arial"/>
+              </a:rPr>
+              <a:t>– </a:t>
+            </a:r>
+            <a:r>
+              <a:rPr b="1" sz="1900">
+                <a:solidFill>
+                  <a:srgbClr val="000000"/>
+                </a:solidFill>
+                <a:latin typeface="Arial"/>
+              </a:rPr>
+              <a:t>Información para la toma de decisiones:</a:t>
+            </a:r>
+            <a:r>
+              <a:rPr sz="1900">
+                <a:solidFill>
+                  <a:srgbClr val="000000"/>
+                </a:solidFill>
+                <a:latin typeface="Arial"/>
+              </a:rPr>
+              <a:t> reportes de consumo y conversión.</a:t>
+            </a:r>
+          </a:p>
+        </p:txBody>
+      </p:sp>
+      <p:sp>
+        <p:nvSpPr>
+          <p:cNvPr id="5" name="TextBox 4"/>
           <p:cNvSpPr txBox="1"/>
           <p:nvPr/>
         </p:nvSpPr>
@@ -5054,7 +5460,7 @@
       </p:sp>
       <p:sp>
         <p:nvSpPr>
-          <p:cNvPr id="7" name="TextBox 6"/>
+          <p:cNvPr id="6" name="TextBox 5"/>
           <p:cNvSpPr txBox="1"/>
           <p:nvPr/>
         </p:nvSpPr>
@@ -5121,7 +5527,7 @@
         </p:nvSpPr>
         <p:spPr>
           <a:xfrm>
-            <a:off x="640080" y="411480"/>
+            <a:off x="640080" y="365760"/>
             <a:ext cx="10911535" cy="822960"/>
           </a:xfrm>
           <a:prstGeom prst="rect">
@@ -5136,13 +5542,13 @@
           <a:lstStyle/>
           <a:p>
             <a:r>
-              <a:rPr sz="3000" b="1">
-                <a:solidFill>
-                  <a:srgbClr val="000000"/>
-                </a:solidFill>
-                <a:latin typeface="Arial"/>
-              </a:rPr>
-              <a:t>¿Qué beneficios se obtendrán?</a:t>
+              <a:rPr sz="2800" b="1">
+                <a:solidFill>
+                  <a:srgbClr val="000000"/>
+                </a:solidFill>
+                <a:latin typeface="Arial"/>
+              </a:rPr>
+              <a:t>Conclusión</a:t>
             </a:r>
           </a:p>
         </p:txBody>
@@ -5155,7 +5561,7 @@
         </p:nvCxnSpPr>
         <p:spPr>
           <a:xfrm>
-            <a:off x="640080" y="1261872"/>
+            <a:off x="640080" y="1170432"/>
             <a:ext cx="4754880" cy="0"/>
           </a:xfrm>
           <a:prstGeom prst="line">
@@ -5190,8 +5596,8 @@
         </p:nvSpPr>
         <p:spPr>
           <a:xfrm>
-            <a:off x="640080" y="1554480"/>
-            <a:ext cx="10911535" cy="4754880"/>
+            <a:off x="640080" y="1463040"/>
+            <a:ext cx="10911535" cy="4206240"/>
           </a:xfrm>
           <a:prstGeom prst="rect">
             <a:avLst/>
@@ -5206,11 +5612,11 @@
           <a:p>
             <a:pPr>
               <a:spcAft>
-                <a:spcPts val="800"/>
+                <a:spcPts val="400"/>
               </a:spcAft>
             </a:pPr>
             <a:r>
-              <a:rPr sz="2000">
+              <a:rPr sz="1900">
                 <a:solidFill>
                   <a:srgbClr val="000000"/>
                 </a:solidFill>
@@ -5219,32 +5625,32 @@
               <a:t>– </a:t>
             </a:r>
             <a:r>
-              <a:rPr b="1" sz="2000">
-                <a:solidFill>
-                  <a:srgbClr val="000000"/>
-                </a:solidFill>
-                <a:latin typeface="Arial"/>
-              </a:rPr>
-              <a:t>Atención más segura:</a:t>
-            </a:r>
-            <a:r>
-              <a:rPr sz="2000">
-                <a:solidFill>
-                  <a:srgbClr val="000000"/>
-                </a:solidFill>
-                <a:latin typeface="Arial"/>
-              </a:rPr>
-              <a:t> validaciones clínicas automáticas.</a:t>
+              <a:rPr b="1" sz="1900">
+                <a:solidFill>
+                  <a:srgbClr val="000000"/>
+                </a:solidFill>
+                <a:latin typeface="Arial"/>
+              </a:rPr>
+              <a:t>Problema identificado:</a:t>
+            </a:r>
+            <a:r>
+              <a:rPr sz="1900">
+                <a:solidFill>
+                  <a:srgbClr val="000000"/>
+                </a:solidFill>
+                <a:latin typeface="Arial"/>
+              </a:rPr>
+              <a:t> consultorio y farmacia desconectados, información arcaica.</a:t>
             </a:r>
           </a:p>
           <a:p>
             <a:pPr>
               <a:spcAft>
-                <a:spcPts val="800"/>
+                <a:spcPts val="400"/>
               </a:spcAft>
             </a:pPr>
             <a:r>
-              <a:rPr sz="2000">
+              <a:rPr sz="1900">
                 <a:solidFill>
                   <a:srgbClr val="000000"/>
                 </a:solidFill>
@@ -5253,32 +5659,32 @@
               <a:t>– </a:t>
             </a:r>
             <a:r>
-              <a:rPr b="1" sz="2000">
-                <a:solidFill>
-                  <a:srgbClr val="000000"/>
-                </a:solidFill>
-                <a:latin typeface="Arial"/>
-              </a:rPr>
-              <a:t>Menos pérdidas:</a:t>
-            </a:r>
-            <a:r>
-              <a:rPr sz="2000">
-                <a:solidFill>
-                  <a:srgbClr val="000000"/>
-                </a:solidFill>
-                <a:latin typeface="Arial"/>
-              </a:rPr>
-              <a:t> control de inventario, caducidades y reposición.</a:t>
+              <a:rPr b="1" sz="1900">
+                <a:solidFill>
+                  <a:srgbClr val="000000"/>
+                </a:solidFill>
+                <a:latin typeface="Arial"/>
+              </a:rPr>
+              <a:t>Estrategia aplicada:</a:t>
+            </a:r>
+            <a:r>
+              <a:rPr sz="1900">
+                <a:solidFill>
+                  <a:srgbClr val="000000"/>
+                </a:solidFill>
+                <a:latin typeface="Arial"/>
+              </a:rPr>
+              <a:t> estandarizar, centralizar y automatizar la operación.</a:t>
             </a:r>
           </a:p>
           <a:p>
             <a:pPr>
               <a:spcAft>
-                <a:spcPts val="800"/>
+                <a:spcPts val="400"/>
               </a:spcAft>
             </a:pPr>
             <a:r>
-              <a:rPr sz="2000">
+              <a:rPr sz="1900">
                 <a:solidFill>
                   <a:srgbClr val="000000"/>
                 </a:solidFill>
@@ -5287,32 +5693,32 @@
               <a:t>– </a:t>
             </a:r>
             <a:r>
-              <a:rPr b="1" sz="2000">
-                <a:solidFill>
-                  <a:srgbClr val="000000"/>
-                </a:solidFill>
-                <a:latin typeface="Arial"/>
-              </a:rPr>
-              <a:t>Trazabilidad:</a:t>
-            </a:r>
-            <a:r>
-              <a:rPr sz="2000">
-                <a:solidFill>
-                  <a:srgbClr val="000000"/>
-                </a:solidFill>
-                <a:latin typeface="Arial"/>
-              </a:rPr>
-              <a:t> vínculo receta–venta y auditoría de inventario.</a:t>
+              <a:rPr b="1" sz="1900">
+                <a:solidFill>
+                  <a:srgbClr val="000000"/>
+                </a:solidFill>
+                <a:latin typeface="Arial"/>
+              </a:rPr>
+              <a:t>Solución implementada:</a:t>
+            </a:r>
+            <a:r>
+              <a:rPr sz="1900">
+                <a:solidFill>
+                  <a:srgbClr val="000000"/>
+                </a:solidFill>
+                <a:latin typeface="Arial"/>
+              </a:rPr>
+              <a:t> base de datos relacional con vistas, SP y triggers.</a:t>
             </a:r>
           </a:p>
           <a:p>
             <a:pPr>
               <a:spcAft>
-                <a:spcPts val="800"/>
+                <a:spcPts val="400"/>
               </a:spcAft>
             </a:pPr>
             <a:r>
-              <a:rPr sz="2000">
+              <a:rPr sz="1900">
                 <a:solidFill>
                   <a:srgbClr val="000000"/>
                 </a:solidFill>
@@ -5321,56 +5727,22 @@
               <a:t>– </a:t>
             </a:r>
             <a:r>
-              <a:rPr b="1" sz="2000">
-                <a:solidFill>
-                  <a:srgbClr val="000000"/>
-                </a:solidFill>
-                <a:latin typeface="Arial"/>
-              </a:rPr>
-              <a:t>Mejores decisiones:</a:t>
-            </a:r>
-            <a:r>
-              <a:rPr sz="2000">
-                <a:solidFill>
-                  <a:srgbClr val="000000"/>
-                </a:solidFill>
-                <a:latin typeface="Arial"/>
-              </a:rPr>
-              <a:t> reportes de consumo para compras.</a:t>
-            </a:r>
-          </a:p>
-          <a:p>
-            <a:pPr>
-              <a:spcAft>
-                <a:spcPts val="800"/>
-              </a:spcAft>
-            </a:pPr>
-            <a:r>
-              <a:rPr sz="2000">
-                <a:solidFill>
-                  <a:srgbClr val="000000"/>
-                </a:solidFill>
-                <a:latin typeface="Arial"/>
-              </a:rPr>
-              <a:t>– </a:t>
-            </a:r>
-            <a:r>
-              <a:rPr b="1" sz="2000">
-                <a:solidFill>
-                  <a:srgbClr val="000000"/>
-                </a:solidFill>
-                <a:latin typeface="Arial"/>
-              </a:rPr>
-              <a:t>Escalabilidad:</a:t>
-            </a:r>
-            <a:r>
-              <a:rPr sz="2000">
-                <a:solidFill>
-                  <a:srgbClr val="000000"/>
-                </a:solidFill>
-                <a:latin typeface="Arial"/>
-              </a:rPr>
-              <a:t> base para un sistema de gestión completo.</a:t>
+              <a:rPr b="1" sz="1900">
+                <a:solidFill>
+                  <a:srgbClr val="000000"/>
+                </a:solidFill>
+                <a:latin typeface="Arial"/>
+              </a:rPr>
+              <a:t>Resultado obtenido:</a:t>
+            </a:r>
+            <a:r>
+              <a:rPr sz="1900">
+                <a:solidFill>
+                  <a:srgbClr val="000000"/>
+                </a:solidFill>
+                <a:latin typeface="Arial"/>
+              </a:rPr>
+              <a:t> atención más segura, menos pérdidas y trazabilidad total.</a:t>
             </a:r>
           </a:p>
         </p:txBody>
@@ -5478,241 +5850,6 @@
         </p:nvSpPr>
         <p:spPr>
           <a:xfrm>
-            <a:off x="640080" y="411480"/>
-            <a:ext cx="10911535" cy="822960"/>
-          </a:xfrm>
-          <a:prstGeom prst="rect">
-            <a:avLst/>
-          </a:prstGeom>
-          <a:noFill/>
-        </p:spPr>
-        <p:txBody>
-          <a:bodyPr wrap="square">
-            <a:spAutoFit/>
-          </a:bodyPr>
-          <a:lstStyle/>
-          <a:p>
-            <a:r>
-              <a:rPr sz="3000" b="1">
-                <a:solidFill>
-                  <a:srgbClr val="000000"/>
-                </a:solidFill>
-                <a:latin typeface="Arial"/>
-              </a:rPr>
-              <a:t>Conclusión</a:t>
-            </a:r>
-          </a:p>
-        </p:txBody>
-      </p:sp>
-      <p:cxnSp>
-        <p:nvCxnSpPr>
-          <p:cNvPr id="3" name="Connector 2"/>
-          <p:cNvCxnSpPr/>
-          <p:nvPr/>
-        </p:nvCxnSpPr>
-        <p:spPr>
-          <a:xfrm>
-            <a:off x="640080" y="1261872"/>
-            <a:ext cx="4754880" cy="0"/>
-          </a:xfrm>
-          <a:prstGeom prst="line">
-            <a:avLst/>
-          </a:prstGeom>
-          <a:ln w="19050">
-            <a:solidFill>
-              <a:srgbClr val="000000"/>
-            </a:solidFill>
-          </a:ln>
-        </p:spPr>
-        <p:style>
-          <a:lnRef idx="2">
-            <a:schemeClr val="accent1"/>
-          </a:lnRef>
-          <a:fillRef idx="0">
-            <a:schemeClr val="accent1"/>
-          </a:fillRef>
-          <a:effectRef idx="1">
-            <a:schemeClr val="accent1"/>
-          </a:effectRef>
-          <a:fontRef idx="minor">
-            <a:schemeClr val="tx1"/>
-          </a:fontRef>
-        </p:style>
-      </p:cxnSp>
-      <p:sp>
-        <p:nvSpPr>
-          <p:cNvPr id="4" name="TextBox 3"/>
-          <p:cNvSpPr txBox="1"/>
-          <p:nvPr/>
-        </p:nvSpPr>
-        <p:spPr>
-          <a:xfrm>
-            <a:off x="640080" y="1554480"/>
-            <a:ext cx="10911535" cy="4754880"/>
-          </a:xfrm>
-          <a:prstGeom prst="rect">
-            <a:avLst/>
-          </a:prstGeom>
-          <a:noFill/>
-        </p:spPr>
-        <p:txBody>
-          <a:bodyPr wrap="square">
-            <a:spAutoFit/>
-          </a:bodyPr>
-          <a:lstStyle/>
-          <a:p>
-            <a:pPr>
-              <a:spcAft>
-                <a:spcPts val="800"/>
-              </a:spcAft>
-            </a:pPr>
-            <a:r>
-              <a:rPr sz="2000">
-                <a:solidFill>
-                  <a:srgbClr val="000000"/>
-                </a:solidFill>
-                <a:latin typeface="Arial"/>
-              </a:rPr>
-              <a:t>– El problema operativo se atacó antes de la solución tecnológica.</a:t>
-            </a:r>
-          </a:p>
-          <a:p>
-            <a:pPr>
-              <a:spcAft>
-                <a:spcPts val="800"/>
-              </a:spcAft>
-            </a:pPr>
-            <a:r>
-              <a:rPr sz="2000">
-                <a:solidFill>
-                  <a:srgbClr val="000000"/>
-                </a:solidFill>
-                <a:latin typeface="Arial"/>
-              </a:rPr>
-              <a:t>– La base de datos integra historial, inventario y ventas con reglas de negocio automatizadas.</a:t>
-            </a:r>
-          </a:p>
-          <a:p>
-            <a:pPr>
-              <a:spcAft>
-                <a:spcPts val="800"/>
-              </a:spcAft>
-            </a:pPr>
-            <a:r>
-              <a:rPr sz="2000">
-                <a:solidFill>
-                  <a:srgbClr val="000000"/>
-                </a:solidFill>
-                <a:latin typeface="Arial"/>
-              </a:rPr>
-              <a:t>– Resultado: atención más segura, menos pérdidas y trazabilidad total.</a:t>
-            </a:r>
-          </a:p>
-        </p:txBody>
-      </p:sp>
-      <p:sp>
-        <p:nvSpPr>
-          <p:cNvPr id="5" name="TextBox 4"/>
-          <p:cNvSpPr txBox="1"/>
-          <p:nvPr/>
-        </p:nvSpPr>
-        <p:spPr>
-          <a:xfrm>
-            <a:off x="640080" y="6400800"/>
-            <a:ext cx="10911535" cy="320040"/>
-          </a:xfrm>
-          <a:prstGeom prst="rect">
-            <a:avLst/>
-          </a:prstGeom>
-          <a:noFill/>
-        </p:spPr>
-        <p:txBody>
-          <a:bodyPr wrap="none">
-            <a:spAutoFit/>
-          </a:bodyPr>
-          <a:lstStyle/>
-          <a:p>
-            <a:r>
-              <a:rPr sz="1000">
-                <a:solidFill>
-                  <a:srgbClr val="404040"/>
-                </a:solidFill>
-                <a:latin typeface="Arial"/>
-              </a:rPr>
-              <a:t>Farmacia con Consultorio Médico</a:t>
-            </a:r>
-          </a:p>
-        </p:txBody>
-      </p:sp>
-      <p:sp>
-        <p:nvSpPr>
-          <p:cNvPr id="6" name="TextBox 5"/>
-          <p:cNvSpPr txBox="1"/>
-          <p:nvPr/>
-        </p:nvSpPr>
-        <p:spPr>
-          <a:xfrm>
-            <a:off x="10637215" y="6400800"/>
-            <a:ext cx="914400" cy="320040"/>
-          </a:xfrm>
-          <a:prstGeom prst="rect">
-            <a:avLst/>
-          </a:prstGeom>
-          <a:noFill/>
-        </p:spPr>
-        <p:txBody>
-          <a:bodyPr wrap="none">
-            <a:spAutoFit/>
-          </a:bodyPr>
-          <a:lstStyle/>
-          <a:p>
-            <a:pPr algn="r"/>
-            <a:r>
-              <a:rPr sz="1000">
-                <a:solidFill>
-                  <a:srgbClr val="404040"/>
-                </a:solidFill>
-                <a:latin typeface="Arial"/>
-              </a:rPr>
-              <a:t>15</a:t>
-            </a:r>
-          </a:p>
-        </p:txBody>
-      </p:sp>
-    </p:spTree>
-  </p:cSld>
-  <p:clrMapOvr>
-    <a:masterClrMapping/>
-  </p:clrMapOvr>
-</p:sld>
-</file>
-
-<file path=ppt/slides/slide18.xml><?xml version="1.0" encoding="utf-8"?>
-<p:sld xmlns:a="http://schemas.openxmlformats.org/drawingml/2006/main" xmlns:p="http://schemas.openxmlformats.org/presentationml/2006/main" xmlns:r="http://schemas.openxmlformats.org/officeDocument/2006/relationships">
-  <p:cSld>
-    <p:bg>
-      <p:bgPr>
-        <a:solidFill>
-          <a:srgbClr val="FFFFFF"/>
-        </a:solidFill>
-        <a:effectLst/>
-      </p:bgPr>
-    </p:bg>
-    <p:spTree>
-      <p:nvGrpSpPr>
-        <p:cNvPr id="1" name=""/>
-        <p:cNvGrpSpPr/>
-        <p:nvPr/>
-      </p:nvGrpSpPr>
-      <p:grpSpPr/>
-      <p:sp>
-        <p:nvSpPr>
-          <p:cNvPr id="2" name="TextBox 1"/>
-          <p:cNvSpPr txBox="1"/>
-          <p:nvPr/>
-        </p:nvSpPr>
-        <p:spPr>
-          <a:xfrm>
             <a:off x="914400" y="2743200"/>
             <a:ext cx="10362895" cy="1463040"/>
           </a:xfrm>
@@ -5790,7 +5927,7 @@
         </p:nvSpPr>
         <p:spPr>
           <a:xfrm>
-            <a:off x="640080" y="411480"/>
+            <a:off x="640080" y="365760"/>
             <a:ext cx="10911535" cy="822960"/>
           </a:xfrm>
           <a:prstGeom prst="rect">
@@ -5805,13 +5942,13 @@
           <a:lstStyle/>
           <a:p>
             <a:r>
-              <a:rPr sz="3000" b="1">
-                <a:solidFill>
-                  <a:srgbClr val="000000"/>
-                </a:solidFill>
-                <a:latin typeface="Arial"/>
-              </a:rPr>
-              <a:t>Agenda</a:t>
+              <a:rPr sz="2800" b="1">
+                <a:solidFill>
+                  <a:srgbClr val="000000"/>
+                </a:solidFill>
+                <a:latin typeface="Arial"/>
+              </a:rPr>
+              <a:t>¿Qué empresa representamos?</a:t>
             </a:r>
           </a:p>
         </p:txBody>
@@ -5824,7 +5961,7 @@
         </p:nvCxnSpPr>
         <p:spPr>
           <a:xfrm>
-            <a:off x="640080" y="1261872"/>
+            <a:off x="640080" y="1170432"/>
             <a:ext cx="4754880" cy="0"/>
           </a:xfrm>
           <a:prstGeom prst="line">
@@ -5859,7 +5996,7 @@
         </p:nvSpPr>
         <p:spPr>
           <a:xfrm>
-            <a:off x="640080" y="1463040"/>
+            <a:off x="640080" y="1371600"/>
             <a:ext cx="10911535" cy="4937760"/>
           </a:xfrm>
           <a:prstGeom prst="rect">
@@ -5874,6 +6011,25 @@
           <a:lstStyle/>
           <a:p>
             <a:pPr>
+              <a:spcBef>
+                <a:spcPts val="600"/>
+              </a:spcBef>
+              <a:spcAft>
+                <a:spcPts val="200"/>
+              </a:spcAft>
+            </a:pPr>
+            <a:r>
+              <a:rPr b="1" sz="1800">
+                <a:solidFill>
+                  <a:srgbClr val="000000"/>
+                </a:solidFill>
+                <a:latin typeface="Arial"/>
+              </a:rPr>
+              <a:t>Quiénes somos</a:t>
+            </a:r>
+          </a:p>
+          <a:p>
+            <a:pPr lvl="1">
               <a:spcAft>
                 <a:spcPts val="400"/>
               </a:spcAft>
@@ -5885,11 +6041,30 @@
                 </a:solidFill>
                 <a:latin typeface="Arial"/>
               </a:rPr>
-              <a:t>1.  La empresa</a:t>
+              <a:t>– Consultorio médico con farmacia asociada.</a:t>
             </a:r>
           </a:p>
           <a:p>
             <a:pPr>
+              <a:spcBef>
+                <a:spcPts val="600"/>
+              </a:spcBef>
+              <a:spcAft>
+                <a:spcPts val="200"/>
+              </a:spcAft>
+            </a:pPr>
+            <a:r>
+              <a:rPr b="1" sz="1800">
+                <a:solidFill>
+                  <a:srgbClr val="000000"/>
+                </a:solidFill>
+                <a:latin typeface="Arial"/>
+              </a:rPr>
+              <a:t>Qué áreas intervienen</a:t>
+            </a:r>
+          </a:p>
+          <a:p>
+            <a:pPr lvl="1">
               <a:spcAft>
                 <a:spcPts val="400"/>
               </a:spcAft>
@@ -5901,11 +6076,30 @@
                 </a:solidFill>
                 <a:latin typeface="Arial"/>
               </a:rPr>
-              <a:t>2.  Problemática actual</a:t>
+              <a:t>– Consultorio (médicos), farmacia (dispensación), compras (proveedores) y administración.</a:t>
             </a:r>
           </a:p>
           <a:p>
             <a:pPr>
+              <a:spcBef>
+                <a:spcPts val="600"/>
+              </a:spcBef>
+              <a:spcAft>
+                <a:spcPts val="200"/>
+              </a:spcAft>
+            </a:pPr>
+            <a:r>
+              <a:rPr b="1" sz="1800">
+                <a:solidFill>
+                  <a:srgbClr val="000000"/>
+                </a:solidFill>
+                <a:latin typeface="Arial"/>
+              </a:rPr>
+              <a:t>Cómo se relacionan el consultorio y la farmacia</a:t>
+            </a:r>
+          </a:p>
+          <a:p>
+            <a:pPr lvl="1">
               <a:spcAft>
                 <a:spcPts val="400"/>
               </a:spcAft>
@@ -5917,151 +6111,7 @@
                 </a:solidFill>
                 <a:latin typeface="Arial"/>
               </a:rPr>
-              <a:t>3.  Impacto</a:t>
-            </a:r>
-          </a:p>
-          <a:p>
-            <a:pPr>
-              <a:spcAft>
-                <a:spcPts val="400"/>
-              </a:spcAft>
-            </a:pPr>
-            <a:r>
-              <a:rPr sz="1800">
-                <a:solidFill>
-                  <a:srgbClr val="000000"/>
-                </a:solidFill>
-                <a:latin typeface="Arial"/>
-              </a:rPr>
-              <a:t>4.  Objetivo del proyecto</a:t>
-            </a:r>
-          </a:p>
-          <a:p>
-            <a:pPr>
-              <a:spcAft>
-                <a:spcPts val="400"/>
-              </a:spcAft>
-            </a:pPr>
-            <a:r>
-              <a:rPr sz="1800">
-                <a:solidFill>
-                  <a:srgbClr val="000000"/>
-                </a:solidFill>
-                <a:latin typeface="Arial"/>
-              </a:rPr>
-              <a:t>5.  Estrategia</a:t>
-            </a:r>
-          </a:p>
-          <a:p>
-            <a:pPr>
-              <a:spcAft>
-                <a:spcPts val="400"/>
-              </a:spcAft>
-            </a:pPr>
-            <a:r>
-              <a:rPr sz="1800">
-                <a:solidFill>
-                  <a:srgbClr val="000000"/>
-                </a:solidFill>
-                <a:latin typeface="Arial"/>
-              </a:rPr>
-              <a:t>6.  Modelo Entidad-Relación</a:t>
-            </a:r>
-          </a:p>
-          <a:p>
-            <a:pPr>
-              <a:spcAft>
-                <a:spcPts val="400"/>
-              </a:spcAft>
-            </a:pPr>
-            <a:r>
-              <a:rPr sz="1800">
-                <a:solidFill>
-                  <a:srgbClr val="000000"/>
-                </a:solidFill>
-                <a:latin typeface="Arial"/>
-              </a:rPr>
-              <a:t>7.  ¿Cómo ayuda la BD? — Gestión de datos</a:t>
-            </a:r>
-          </a:p>
-          <a:p>
-            <a:pPr>
-              <a:spcAft>
-                <a:spcPts val="400"/>
-              </a:spcAft>
-            </a:pPr>
-            <a:r>
-              <a:rPr sz="1800">
-                <a:solidFill>
-                  <a:srgbClr val="000000"/>
-                </a:solidFill>
-                <a:latin typeface="Arial"/>
-              </a:rPr>
-              <a:t>8.  ¿Cómo ayuda la BD? — Automatización</a:t>
-            </a:r>
-          </a:p>
-          <a:p>
-            <a:pPr>
-              <a:spcAft>
-                <a:spcPts val="400"/>
-              </a:spcAft>
-            </a:pPr>
-            <a:r>
-              <a:rPr sz="1800">
-                <a:solidFill>
-                  <a:srgbClr val="000000"/>
-                </a:solidFill>
-                <a:latin typeface="Arial"/>
-              </a:rPr>
-              <a:t>9.  Conexión Java (JDBC)</a:t>
-            </a:r>
-          </a:p>
-          <a:p>
-            <a:pPr>
-              <a:spcAft>
-                <a:spcPts val="400"/>
-              </a:spcAft>
-            </a:pPr>
-            <a:r>
-              <a:rPr sz="1800">
-                <a:solidFill>
-                  <a:srgbClr val="000000"/>
-                </a:solidFill>
-                <a:latin typeface="Arial"/>
-              </a:rPr>
-              <a:t>10.  Validación</a:t>
-            </a:r>
-          </a:p>
-          <a:p>
-            <a:pPr>
-              <a:spcAft>
-                <a:spcPts val="400"/>
-              </a:spcAft>
-            </a:pPr>
-            <a:r>
-              <a:rPr sz="1800">
-                <a:solidFill>
-                  <a:srgbClr val="000000"/>
-                </a:solidFill>
-                <a:latin typeface="Arial"/>
-              </a:rPr>
-              <a:t>11.  Beneficios</a:t>
-            </a:r>
-          </a:p>
-          <a:p>
-            <a:pPr>
-              <a:spcAft>
-                <a:spcPts val="400"/>
-              </a:spcAft>
-            </a:pPr>
-            <a:r>
-              <a:rPr sz="1800">
-                <a:solidFill>
-                  <a:srgbClr val="000000"/>
-                </a:solidFill>
-                <a:latin typeface="Arial"/>
-              </a:rPr>
-              <a:t>12.  Conclusión</a:t>
+              <a:t>– El médico consulta y emite la receta; la farmacia la surte y registra la venta.</a:t>
             </a:r>
           </a:p>
         </p:txBody>
@@ -6169,7 +6219,7 @@
         </p:nvSpPr>
         <p:spPr>
           <a:xfrm>
-            <a:off x="640080" y="411480"/>
+            <a:off x="640080" y="365760"/>
             <a:ext cx="10911535" cy="822960"/>
           </a:xfrm>
           <a:prstGeom prst="rect">
@@ -6184,13 +6234,13 @@
           <a:lstStyle/>
           <a:p>
             <a:r>
-              <a:rPr sz="3000" b="1">
-                <a:solidFill>
-                  <a:srgbClr val="000000"/>
-                </a:solidFill>
-                <a:latin typeface="Arial"/>
-              </a:rPr>
-              <a:t>¿Qué empresa representamos?</a:t>
+              <a:rPr sz="2800" b="1">
+                <a:solidFill>
+                  <a:srgbClr val="000000"/>
+                </a:solidFill>
+                <a:latin typeface="Arial"/>
+              </a:rPr>
+              <a:t>¿Cuál es la problemática actual?</a:t>
             </a:r>
           </a:p>
         </p:txBody>
@@ -6203,7 +6253,7 @@
         </p:nvCxnSpPr>
         <p:spPr>
           <a:xfrm>
-            <a:off x="640080" y="1261872"/>
+            <a:off x="640080" y="1170432"/>
             <a:ext cx="4754880" cy="0"/>
           </a:xfrm>
           <a:prstGeom prst="line">
@@ -6238,8 +6288,8 @@
         </p:nvSpPr>
         <p:spPr>
           <a:xfrm>
-            <a:off x="640080" y="1554480"/>
-            <a:ext cx="10911535" cy="4754880"/>
+            <a:off x="640080" y="1280160"/>
+            <a:ext cx="10911535" cy="4937760"/>
           </a:xfrm>
           <a:prstGeom prst="rect">
             <a:avLst/>
@@ -6253,50 +6303,187 @@
           <a:lstStyle/>
           <a:p>
             <a:pPr>
+              <a:spcBef>
+                <a:spcPts val="600"/>
+              </a:spcBef>
               <a:spcAft>
-                <a:spcPts val="800"/>
+                <a:spcPts val="200"/>
               </a:spcAft>
             </a:pPr>
             <a:r>
-              <a:rPr sz="2000">
-                <a:solidFill>
-                  <a:srgbClr val="000000"/>
-                </a:solidFill>
-                <a:latin typeface="Arial"/>
-              </a:rPr>
-              <a:t>– Consultorio médico con farmacia asociada.</a:t>
+              <a:rPr b="1" sz="1600">
+                <a:solidFill>
+                  <a:srgbClr val="000000"/>
+                </a:solidFill>
+                <a:latin typeface="Arial"/>
+              </a:rPr>
+              <a:t>Situación actual</a:t>
+            </a:r>
+          </a:p>
+          <a:p>
+            <a:pPr lvl="1">
+              <a:spcAft>
+                <a:spcPts val="400"/>
+              </a:spcAft>
+            </a:pPr>
+            <a:r>
+              <a:rPr sz="1500">
+                <a:solidFill>
+                  <a:srgbClr val="000000"/>
+                </a:solidFill>
+                <a:latin typeface="Arial"/>
+              </a:rPr>
+              <a:t>– Desconexión entre la farmacia y el consultorio.</a:t>
+            </a:r>
+          </a:p>
+          <a:p>
+            <a:pPr lvl="1">
+              <a:spcAft>
+                <a:spcPts val="400"/>
+              </a:spcAft>
+            </a:pPr>
+            <a:r>
+              <a:rPr sz="1500">
+                <a:solidFill>
+                  <a:srgbClr val="000000"/>
+                </a:solidFill>
+                <a:latin typeface="Arial"/>
+              </a:rPr>
+              <a:t>– Operan como dos negocios distintos: información y procesos separados.</a:t>
+            </a:r>
+          </a:p>
+          <a:p>
+            <a:pPr lvl="1">
+              <a:spcAft>
+                <a:spcPts val="400"/>
+              </a:spcAft>
+            </a:pPr>
+            <a:r>
+              <a:rPr sz="1500">
+                <a:solidFill>
+                  <a:srgbClr val="000000"/>
+                </a:solidFill>
+                <a:latin typeface="Arial"/>
+              </a:rPr>
+              <a:t>– Experiencia de usuario fragmentada: sin datos de fidelidad ni conocimiento de la conversión de recetas.</a:t>
             </a:r>
           </a:p>
           <a:p>
             <a:pPr>
+              <a:spcBef>
+                <a:spcPts val="600"/>
+              </a:spcBef>
               <a:spcAft>
-                <a:spcPts val="800"/>
+                <a:spcPts val="200"/>
               </a:spcAft>
             </a:pPr>
             <a:r>
-              <a:rPr sz="2000">
-                <a:solidFill>
-                  <a:srgbClr val="000000"/>
-                </a:solidFill>
-                <a:latin typeface="Arial"/>
-              </a:rPr>
-              <a:t>– Atiende consultas, emite recetas y surte medicamentos en el mismo lugar.</a:t>
+              <a:rPr b="1" sz="1600">
+                <a:solidFill>
+                  <a:srgbClr val="000000"/>
+                </a:solidFill>
+                <a:latin typeface="Arial"/>
+              </a:rPr>
+              <a:t>Manejo de la información</a:t>
+            </a:r>
+          </a:p>
+          <a:p>
+            <a:pPr lvl="1">
+              <a:spcAft>
+                <a:spcPts val="400"/>
+              </a:spcAft>
+            </a:pPr>
+            <a:r>
+              <a:rPr sz="1500">
+                <a:solidFill>
+                  <a:srgbClr val="000000"/>
+                </a:solidFill>
+                <a:latin typeface="Arial"/>
+              </a:rPr>
+              <a:t>– La información se administra de forma arcaica.</a:t>
+            </a:r>
+          </a:p>
+          <a:p>
+            <a:pPr lvl="1">
+              <a:spcAft>
+                <a:spcPts val="400"/>
+              </a:spcAft>
+            </a:pPr>
+            <a:r>
+              <a:rPr sz="1500">
+                <a:solidFill>
+                  <a:srgbClr val="000000"/>
+                </a:solidFill>
+                <a:latin typeface="Arial"/>
+              </a:rPr>
+              <a:t>– Uso de papel; datos dispersos, no centralizados ni conectados para generar información estratégica.</a:t>
             </a:r>
           </a:p>
           <a:p>
             <a:pPr>
+              <a:spcBef>
+                <a:spcPts val="600"/>
+              </a:spcBef>
               <a:spcAft>
-                <a:spcPts val="800"/>
+                <a:spcPts val="200"/>
               </a:spcAft>
             </a:pPr>
             <a:r>
-              <a:rPr sz="2000">
-                <a:solidFill>
-                  <a:srgbClr val="000000"/>
-                </a:solidFill>
-                <a:latin typeface="Arial"/>
-              </a:rPr>
-              <a:t>– Áreas involucradas: consultorio (médicos), farmacia (dispensación), compras (proveedores) y administración.</a:t>
+              <a:rPr b="1" sz="1600">
+                <a:solidFill>
+                  <a:srgbClr val="000000"/>
+                </a:solidFill>
+                <a:latin typeface="Arial"/>
+              </a:rPr>
+              <a:t>Principales problemas identificados</a:t>
+            </a:r>
+          </a:p>
+          <a:p>
+            <a:pPr lvl="1">
+              <a:spcAft>
+                <a:spcPts val="400"/>
+              </a:spcAft>
+            </a:pPr>
+            <a:r>
+              <a:rPr sz="1500">
+                <a:solidFill>
+                  <a:srgbClr val="000000"/>
+                </a:solidFill>
+                <a:latin typeface="Arial"/>
+              </a:rPr>
+              <a:t>– Ausencia de automatización.</a:t>
+            </a:r>
+          </a:p>
+          <a:p>
+            <a:pPr lvl="1">
+              <a:spcAft>
+                <a:spcPts val="400"/>
+              </a:spcAft>
+            </a:pPr>
+            <a:r>
+              <a:rPr sz="1500">
+                <a:solidFill>
+                  <a:srgbClr val="000000"/>
+                </a:solidFill>
+                <a:latin typeface="Arial"/>
+              </a:rPr>
+              <a:t>– Desabasto de medicamentos clave y mermas por caducidad no detectada.</a:t>
+            </a:r>
+          </a:p>
+          <a:p>
+            <a:pPr lvl="1">
+              <a:spcAft>
+                <a:spcPts val="400"/>
+              </a:spcAft>
+            </a:pPr>
+            <a:r>
+              <a:rPr sz="1500">
+                <a:solidFill>
+                  <a:srgbClr val="000000"/>
+                </a:solidFill>
+                <a:latin typeface="Arial"/>
+              </a:rPr>
+              <a:t>– Procesos manuales que retrasan la reposición y provocan errores de dispensación.</a:t>
             </a:r>
           </a:p>
         </p:txBody>
@@ -6404,7 +6591,7 @@
         </p:nvSpPr>
         <p:spPr>
           <a:xfrm>
-            <a:off x="640080" y="411480"/>
+            <a:off x="640080" y="365760"/>
             <a:ext cx="10911535" cy="822960"/>
           </a:xfrm>
           <a:prstGeom prst="rect">
@@ -6419,13 +6606,13 @@
           <a:lstStyle/>
           <a:p>
             <a:r>
-              <a:rPr sz="3000" b="1">
-                <a:solidFill>
-                  <a:srgbClr val="000000"/>
-                </a:solidFill>
-                <a:latin typeface="Arial"/>
-              </a:rPr>
-              <a:t>¿Cuál es su problemática actual?</a:t>
+              <a:rPr sz="2800" b="1">
+                <a:solidFill>
+                  <a:srgbClr val="000000"/>
+                </a:solidFill>
+                <a:latin typeface="Arial"/>
+              </a:rPr>
+              <a:t>¿Cuál es el impacto?</a:t>
             </a:r>
           </a:p>
         </p:txBody>
@@ -6438,7 +6625,7 @@
         </p:nvCxnSpPr>
         <p:spPr>
           <a:xfrm>
-            <a:off x="640080" y="1261872"/>
+            <a:off x="640080" y="1170432"/>
             <a:ext cx="4754880" cy="0"/>
           </a:xfrm>
           <a:prstGeom prst="line">
@@ -6473,8 +6660,8 @@
         </p:nvSpPr>
         <p:spPr>
           <a:xfrm>
-            <a:off x="640080" y="1554480"/>
-            <a:ext cx="10911535" cy="4754880"/>
+            <a:off x="640080" y="1371600"/>
+            <a:ext cx="10911535" cy="4937760"/>
           </a:xfrm>
           <a:prstGeom prst="rect">
             <a:avLst/>
@@ -6488,66 +6675,155 @@
           <a:lstStyle/>
           <a:p>
             <a:pPr>
+              <a:spcBef>
+                <a:spcPts val="600"/>
+              </a:spcBef>
               <a:spcAft>
-                <a:spcPts val="800"/>
+                <a:spcPts val="200"/>
               </a:spcAft>
             </a:pPr>
             <a:r>
-              <a:rPr sz="2000">
-                <a:solidFill>
-                  <a:srgbClr val="000000"/>
-                </a:solidFill>
-                <a:latin typeface="Arial"/>
-              </a:rPr>
-              <a:t>– Historiales clínicos en papel: se extravían y fragmentan la atención.</a:t>
+              <a:rPr b="1" sz="1800">
+                <a:solidFill>
+                  <a:srgbClr val="000000"/>
+                </a:solidFill>
+                <a:latin typeface="Arial"/>
+              </a:rPr>
+              <a:t>Impacto en los pacientes</a:t>
+            </a:r>
+          </a:p>
+          <a:p>
+            <a:pPr lvl="1">
+              <a:spcAft>
+                <a:spcPts val="400"/>
+              </a:spcAft>
+            </a:pPr>
+            <a:r>
+              <a:rPr sz="1800">
+                <a:solidFill>
+                  <a:srgbClr val="000000"/>
+                </a:solidFill>
+                <a:latin typeface="Arial"/>
+              </a:rPr>
+              <a:t>– Experiencias distintas entre consultorio y farmacia.</a:t>
+            </a:r>
+          </a:p>
+          <a:p>
+            <a:pPr lvl="1">
+              <a:spcAft>
+                <a:spcPts val="400"/>
+              </a:spcAft>
+            </a:pPr>
+            <a:r>
+              <a:rPr sz="1800">
+                <a:solidFill>
+                  <a:srgbClr val="000000"/>
+                </a:solidFill>
+                <a:latin typeface="Arial"/>
+              </a:rPr>
+              <a:t>– Creación de doble perfil.</a:t>
             </a:r>
           </a:p>
           <a:p>
             <a:pPr>
+              <a:spcBef>
+                <a:spcPts val="600"/>
+              </a:spcBef>
               <a:spcAft>
-                <a:spcPts val="800"/>
+                <a:spcPts val="200"/>
               </a:spcAft>
             </a:pPr>
             <a:r>
-              <a:rPr sz="2000">
-                <a:solidFill>
-                  <a:srgbClr val="000000"/>
-                </a:solidFill>
-                <a:latin typeface="Arial"/>
-              </a:rPr>
-              <a:t>– Inventario sin control: desabasto de fármacos clave y mermas por caducidad.</a:t>
+              <a:rPr b="1" sz="1800">
+                <a:solidFill>
+                  <a:srgbClr val="000000"/>
+                </a:solidFill>
+                <a:latin typeface="Arial"/>
+              </a:rPr>
+              <a:t>Impacto en la atención</a:t>
+            </a:r>
+          </a:p>
+          <a:p>
+            <a:pPr lvl="1">
+              <a:spcAft>
+                <a:spcPts val="400"/>
+              </a:spcAft>
+            </a:pPr>
+            <a:r>
+              <a:rPr sz="1800">
+                <a:solidFill>
+                  <a:srgbClr val="000000"/>
+                </a:solidFill>
+                <a:latin typeface="Arial"/>
+              </a:rPr>
+              <a:t>– Atención lenta y fragmentada.</a:t>
             </a:r>
           </a:p>
           <a:p>
             <a:pPr>
+              <a:spcBef>
+                <a:spcPts val="600"/>
+              </a:spcBef>
               <a:spcAft>
-                <a:spcPts val="800"/>
+                <a:spcPts val="200"/>
               </a:spcAft>
             </a:pPr>
             <a:r>
-              <a:rPr sz="2000">
-                <a:solidFill>
-                  <a:srgbClr val="000000"/>
-                </a:solidFill>
-                <a:latin typeface="Arial"/>
-              </a:rPr>
-              <a:t>– Recetas y ventas desvinculadas: no hay trazabilidad receta–venta.</a:t>
-            </a:r>
-          </a:p>
-          <a:p>
-            <a:pPr>
+              <a:rPr b="1" sz="1800">
+                <a:solidFill>
+                  <a:srgbClr val="000000"/>
+                </a:solidFill>
+                <a:latin typeface="Arial"/>
+              </a:rPr>
+              <a:t>Impacto en la farmacia</a:t>
+            </a:r>
+          </a:p>
+          <a:p>
+            <a:pPr lvl="1">
               <a:spcAft>
-                <a:spcPts val="800"/>
+                <a:spcPts val="400"/>
               </a:spcAft>
             </a:pPr>
             <a:r>
-              <a:rPr sz="2000">
-                <a:solidFill>
-                  <a:srgbClr val="000000"/>
-                </a:solidFill>
-                <a:latin typeface="Arial"/>
-              </a:rPr>
-              <a:t>– Procesos manuales: reposición tardía y errores de dispensación.</a:t>
+              <a:rPr sz="1800">
+                <a:solidFill>
+                  <a:srgbClr val="000000"/>
+                </a:solidFill>
+                <a:latin typeface="Arial"/>
+              </a:rPr>
+              <a:t>– Desconocimiento del rendimiento del negocio.</a:t>
+            </a:r>
+          </a:p>
+          <a:p>
+            <a:pPr lvl="1">
+              <a:spcAft>
+                <a:spcPts val="400"/>
+              </a:spcAft>
+            </a:pPr>
+            <a:r>
+              <a:rPr sz="1800">
+                <a:solidFill>
+                  <a:srgbClr val="000000"/>
+                </a:solidFill>
+                <a:latin typeface="Arial"/>
+              </a:rPr>
+              <a:t>– Pérdida de ventas.</a:t>
+            </a:r>
+          </a:p>
+          <a:p>
+            <a:pPr lvl="1">
+              <a:spcAft>
+                <a:spcPts val="400"/>
+              </a:spcAft>
+            </a:pPr>
+            <a:r>
+              <a:rPr sz="1800">
+                <a:solidFill>
+                  <a:srgbClr val="000000"/>
+                </a:solidFill>
+                <a:latin typeface="Arial"/>
+              </a:rPr>
+              <a:t>– Ausencia de competitividad.</a:t>
             </a:r>
           </a:p>
         </p:txBody>
@@ -6655,7 +6931,7 @@
         </p:nvSpPr>
         <p:spPr>
           <a:xfrm>
-            <a:off x="640080" y="411480"/>
+            <a:off x="640080" y="365760"/>
             <a:ext cx="10911535" cy="822960"/>
           </a:xfrm>
           <a:prstGeom prst="rect">
@@ -6670,13 +6946,13 @@
           <a:lstStyle/>
           <a:p>
             <a:r>
-              <a:rPr sz="3000" b="1">
-                <a:solidFill>
-                  <a:srgbClr val="000000"/>
-                </a:solidFill>
-                <a:latin typeface="Arial"/>
-              </a:rPr>
-              <a:t>¿Cuál es su impacto?</a:t>
+              <a:rPr sz="2800" b="1">
+                <a:solidFill>
+                  <a:srgbClr val="000000"/>
+                </a:solidFill>
+                <a:latin typeface="Arial"/>
+              </a:rPr>
+              <a:t>¿Cuál es la causa raíz?</a:t>
             </a:r>
           </a:p>
         </p:txBody>
@@ -6689,7 +6965,7 @@
         </p:nvCxnSpPr>
         <p:spPr>
           <a:xfrm>
-            <a:off x="640080" y="1261872"/>
+            <a:off x="640080" y="1170432"/>
             <a:ext cx="4754880" cy="0"/>
           </a:xfrm>
           <a:prstGeom prst="line">
@@ -6724,8 +7000,8 @@
         </p:nvSpPr>
         <p:spPr>
           <a:xfrm>
-            <a:off x="640080" y="1554480"/>
-            <a:ext cx="10911535" cy="4754880"/>
+            <a:off x="640080" y="1371600"/>
+            <a:ext cx="10911535" cy="4937760"/>
           </a:xfrm>
           <a:prstGeom prst="rect">
             <a:avLst/>
@@ -6739,138 +7015,155 @@
           <a:lstStyle/>
           <a:p>
             <a:pPr>
+              <a:spcBef>
+                <a:spcPts val="600"/>
+              </a:spcBef>
               <a:spcAft>
-                <a:spcPts val="800"/>
+                <a:spcPts val="200"/>
               </a:spcAft>
             </a:pPr>
             <a:r>
-              <a:rPr sz="2000">
-                <a:solidFill>
-                  <a:srgbClr val="000000"/>
-                </a:solidFill>
-                <a:latin typeface="Arial"/>
-              </a:rPr>
-              <a:t>– </a:t>
-            </a:r>
-            <a:r>
-              <a:rPr b="1" sz="2000">
-                <a:solidFill>
-                  <a:srgbClr val="000000"/>
-                </a:solidFill>
-                <a:latin typeface="Arial"/>
-              </a:rPr>
-              <a:t>Clínico:</a:t>
-            </a:r>
-            <a:r>
-              <a:rPr sz="2000">
-                <a:solidFill>
-                  <a:srgbClr val="000000"/>
-                </a:solidFill>
-                <a:latin typeface="Arial"/>
-              </a:rPr>
-              <a:t> riesgo para el paciente por alergias/interacciones no detectadas.</a:t>
+              <a:rPr b="1" sz="1800">
+                <a:solidFill>
+                  <a:srgbClr val="000000"/>
+                </a:solidFill>
+                <a:latin typeface="Arial"/>
+              </a:rPr>
+              <a:t>Falta de integración de la información</a:t>
+            </a:r>
+          </a:p>
+          <a:p>
+            <a:pPr lvl="1">
+              <a:spcAft>
+                <a:spcPts val="400"/>
+              </a:spcAft>
+            </a:pPr>
+            <a:r>
+              <a:rPr sz="1800">
+                <a:solidFill>
+                  <a:srgbClr val="000000"/>
+                </a:solidFill>
+                <a:latin typeface="Arial"/>
+              </a:rPr>
+              <a:t>– Consultorio y farmacia no comparten una misma fuente de datos.</a:t>
+            </a:r>
+          </a:p>
+          <a:p>
+            <a:pPr lvl="1">
+              <a:spcAft>
+                <a:spcPts val="400"/>
+              </a:spcAft>
+            </a:pPr>
+            <a:r>
+              <a:rPr sz="1800">
+                <a:solidFill>
+                  <a:srgbClr val="000000"/>
+                </a:solidFill>
+                <a:latin typeface="Arial"/>
+              </a:rPr>
+              <a:t>– Información dispersa y en papel: se duplica y no se conecta.</a:t>
             </a:r>
           </a:p>
           <a:p>
             <a:pPr>
+              <a:spcBef>
+                <a:spcPts val="600"/>
+              </a:spcBef>
               <a:spcAft>
-                <a:spcPts val="800"/>
+                <a:spcPts val="200"/>
               </a:spcAft>
             </a:pPr>
             <a:r>
-              <a:rPr sz="2000">
-                <a:solidFill>
-                  <a:srgbClr val="000000"/>
-                </a:solidFill>
-                <a:latin typeface="Arial"/>
-              </a:rPr>
-              <a:t>– </a:t>
-            </a:r>
-            <a:r>
-              <a:rPr b="1" sz="2000">
-                <a:solidFill>
-                  <a:srgbClr val="000000"/>
-                </a:solidFill>
-                <a:latin typeface="Arial"/>
-              </a:rPr>
-              <a:t>Económico:</a:t>
-            </a:r>
-            <a:r>
-              <a:rPr sz="2000">
-                <a:solidFill>
-                  <a:srgbClr val="000000"/>
-                </a:solidFill>
-                <a:latin typeface="Arial"/>
-              </a:rPr>
-              <a:t> pérdidas por caducidad, desabasto y ventas no registradas.</a:t>
+              <a:rPr b="1" sz="1800">
+                <a:solidFill>
+                  <a:srgbClr val="000000"/>
+                </a:solidFill>
+                <a:latin typeface="Arial"/>
+              </a:rPr>
+              <a:t>Procesos manuales</a:t>
+            </a:r>
+          </a:p>
+          <a:p>
+            <a:pPr lvl="1">
+              <a:spcAft>
+                <a:spcPts val="400"/>
+              </a:spcAft>
+            </a:pPr>
+            <a:r>
+              <a:rPr sz="1800">
+                <a:solidFill>
+                  <a:srgbClr val="000000"/>
+                </a:solidFill>
+                <a:latin typeface="Arial"/>
+              </a:rPr>
+              <a:t>– Operación dependiente de tareas manuales, sin conexión entre áreas.</a:t>
+            </a:r>
+          </a:p>
+          <a:p>
+            <a:pPr lvl="1">
+              <a:spcAft>
+                <a:spcPts val="400"/>
+              </a:spcAft>
+            </a:pPr>
+            <a:r>
+              <a:rPr sz="1800">
+                <a:solidFill>
+                  <a:srgbClr val="000000"/>
+                </a:solidFill>
+                <a:latin typeface="Arial"/>
+              </a:rPr>
+              <a:t>– No hay un flujo estandarizado de la información.</a:t>
             </a:r>
           </a:p>
           <a:p>
             <a:pPr>
+              <a:spcBef>
+                <a:spcPts val="600"/>
+              </a:spcBef>
               <a:spcAft>
-                <a:spcPts val="800"/>
+                <a:spcPts val="200"/>
               </a:spcAft>
             </a:pPr>
             <a:r>
-              <a:rPr sz="2000">
-                <a:solidFill>
-                  <a:srgbClr val="000000"/>
-                </a:solidFill>
-                <a:latin typeface="Arial"/>
-              </a:rPr>
-              <a:t>– </a:t>
-            </a:r>
-            <a:r>
-              <a:rPr b="1" sz="2000">
-                <a:solidFill>
-                  <a:srgbClr val="000000"/>
-                </a:solidFill>
-                <a:latin typeface="Arial"/>
-              </a:rPr>
-              <a:t>Operativo:</a:t>
-            </a:r>
-            <a:r>
-              <a:rPr sz="2000">
-                <a:solidFill>
-                  <a:srgbClr val="000000"/>
-                </a:solidFill>
-                <a:latin typeface="Arial"/>
-              </a:rPr>
-              <a:t> decisiones de compra sin datos y auditorías difíciles.</a:t>
-            </a:r>
-          </a:p>
-          <a:p>
-            <a:pPr>
+              <a:rPr b="1" sz="1800">
+                <a:solidFill>
+                  <a:srgbClr val="000000"/>
+                </a:solidFill>
+                <a:latin typeface="Arial"/>
+              </a:rPr>
+              <a:t>Falta de validaciones y controles</a:t>
+            </a:r>
+          </a:p>
+          <a:p>
+            <a:pPr lvl="1">
               <a:spcAft>
-                <a:spcPts val="800"/>
+                <a:spcPts val="400"/>
               </a:spcAft>
             </a:pPr>
             <a:r>
-              <a:rPr sz="2000">
-                <a:solidFill>
-                  <a:srgbClr val="000000"/>
-                </a:solidFill>
-                <a:latin typeface="Arial"/>
-              </a:rPr>
-              <a:t>– </a:t>
-            </a:r>
-            <a:r>
-              <a:rPr b="1" sz="2000">
-                <a:solidFill>
-                  <a:srgbClr val="000000"/>
-                </a:solidFill>
-                <a:latin typeface="Arial"/>
-              </a:rPr>
-              <a:t>Reputacional:</a:t>
-            </a:r>
-            <a:r>
-              <a:rPr sz="2000">
-                <a:solidFill>
-                  <a:srgbClr val="000000"/>
-                </a:solidFill>
-                <a:latin typeface="Arial"/>
-              </a:rPr>
-              <a:t> menor confianza del paciente en la atención.</a:t>
+              <a:rPr sz="1800">
+                <a:solidFill>
+                  <a:srgbClr val="000000"/>
+                </a:solidFill>
+                <a:latin typeface="Arial"/>
+              </a:rPr>
+              <a:t>– Sin reglas de negocio aplicadas de forma automática.</a:t>
+            </a:r>
+          </a:p>
+          <a:p>
+            <a:pPr lvl="1">
+              <a:spcAft>
+                <a:spcPts val="400"/>
+              </a:spcAft>
+            </a:pPr>
+            <a:r>
+              <a:rPr sz="1800">
+                <a:solidFill>
+                  <a:srgbClr val="000000"/>
+                </a:solidFill>
+                <a:latin typeface="Arial"/>
+              </a:rPr>
+              <a:t>– Sin control de inventario, caducidades ni trazabilidad receta–venta.</a:t>
             </a:r>
           </a:p>
         </p:txBody>
@@ -6978,7 +7271,7 @@
         </p:nvSpPr>
         <p:spPr>
           <a:xfrm>
-            <a:off x="640080" y="411480"/>
+            <a:off x="640080" y="365760"/>
             <a:ext cx="10911535" cy="822960"/>
           </a:xfrm>
           <a:prstGeom prst="rect">
@@ -6993,13 +7286,13 @@
           <a:lstStyle/>
           <a:p>
             <a:r>
-              <a:rPr sz="3000" b="1">
-                <a:solidFill>
-                  <a:srgbClr val="000000"/>
-                </a:solidFill>
-                <a:latin typeface="Arial"/>
-              </a:rPr>
-              <a:t>Objetivo del proyecto (SMART)</a:t>
+              <a:rPr sz="2800" b="1">
+                <a:solidFill>
+                  <a:srgbClr val="000000"/>
+                </a:solidFill>
+                <a:latin typeface="Arial"/>
+              </a:rPr>
+              <a:t>¿Qué estrategia debemos seguir?</a:t>
             </a:r>
           </a:p>
         </p:txBody>
@@ -7012,7 +7305,7 @@
         </p:nvCxnSpPr>
         <p:spPr>
           <a:xfrm>
-            <a:off x="640080" y="1261872"/>
+            <a:off x="640080" y="1170432"/>
             <a:ext cx="4754880" cy="0"/>
           </a:xfrm>
           <a:prstGeom prst="line">
@@ -7041,68 +7334,14 @@
       </p:cxnSp>
       <p:sp>
         <p:nvSpPr>
-          <p:cNvPr id="4" name="Rectangle 3"/>
-          <p:cNvSpPr/>
-          <p:nvPr/>
-        </p:nvSpPr>
-        <p:spPr>
-          <a:xfrm>
-            <a:off x="640080" y="1463040"/>
-            <a:ext cx="10911535" cy="1371600"/>
-          </a:xfrm>
-          <a:prstGeom prst="rect">
-            <a:avLst/>
-          </a:prstGeom>
-          <a:solidFill>
-            <a:srgbClr val="FFFFFF"/>
-          </a:solidFill>
-          <a:ln w="12700">
-            <a:solidFill>
-              <a:srgbClr val="000000"/>
-            </a:solidFill>
-          </a:ln>
-        </p:spPr>
-        <p:style>
-          <a:lnRef idx="1">
-            <a:schemeClr val="accent1"/>
-          </a:lnRef>
-          <a:fillRef idx="3">
-            <a:schemeClr val="accent1"/>
-          </a:fillRef>
-          <a:effectRef idx="2">
-            <a:schemeClr val="accent1"/>
-          </a:effectRef>
-          <a:fontRef idx="minor">
-            <a:schemeClr val="lt1"/>
-          </a:fontRef>
-        </p:style>
-        <p:txBody>
-          <a:bodyPr rtlCol="0" anchor="ctr" wrap="square" lIns="182880" rIns="182880"/>
-          <a:lstStyle/>
-          <a:p>
-            <a:pPr algn="ctr"/>
-            <a:r>
-              <a:rPr sz="1800">
-                <a:solidFill>
-                  <a:srgbClr val="000000"/>
-                </a:solidFill>
-                <a:latin typeface="Arial"/>
-              </a:rPr>
-              <a:t>Implementar una base de datos relacional para el consultorio-farmacia que centralice historial clínico, inventario y ventas, con validaciones automáticas, reduciendo errores de dispensación y desabasto.</a:t>
-            </a:r>
-          </a:p>
-        </p:txBody>
-      </p:sp>
-      <p:sp>
-        <p:nvSpPr>
-          <p:cNvPr id="5" name="TextBox 4"/>
+          <p:cNvPr id="4" name="TextBox 3"/>
           <p:cNvSpPr txBox="1"/>
           <p:nvPr/>
         </p:nvSpPr>
         <p:spPr>
           <a:xfrm>
-            <a:off x="640080" y="3017520"/>
-            <a:ext cx="10911535" cy="2926080"/>
+            <a:off x="640080" y="1463040"/>
+            <a:ext cx="10911535" cy="3657600"/>
           </a:xfrm>
           <a:prstGeom prst="rect">
             <a:avLst/>
@@ -7117,11 +7356,11 @@
           <a:p>
             <a:pPr>
               <a:spcAft>
-                <a:spcPts val="800"/>
+                <a:spcPts val="400"/>
               </a:spcAft>
             </a:pPr>
             <a:r>
-              <a:rPr sz="1800">
+              <a:rPr sz="1900">
                 <a:solidFill>
                   <a:srgbClr val="000000"/>
                 </a:solidFill>
@@ -7130,32 +7369,32 @@
               <a:t>– </a:t>
             </a:r>
             <a:r>
-              <a:rPr b="1" sz="1800">
-                <a:solidFill>
-                  <a:srgbClr val="000000"/>
-                </a:solidFill>
-                <a:latin typeface="Arial"/>
-              </a:rPr>
-              <a:t>Específico:</a:t>
-            </a:r>
-            <a:r>
-              <a:rPr sz="1800">
-                <a:solidFill>
-                  <a:srgbClr val="000000"/>
-                </a:solidFill>
-                <a:latin typeface="Arial"/>
-              </a:rPr>
-              <a:t> historial, inventario y recetas en una sola base.</a:t>
+              <a:rPr b="1" sz="1900">
+                <a:solidFill>
+                  <a:srgbClr val="000000"/>
+                </a:solidFill>
+                <a:latin typeface="Arial"/>
+              </a:rPr>
+              <a:t>Entender las reglas del negocio:</a:t>
+            </a:r>
+            <a:r>
+              <a:rPr sz="1900">
+                <a:solidFill>
+                  <a:srgbClr val="000000"/>
+                </a:solidFill>
+                <a:latin typeface="Arial"/>
+              </a:rPr>
+              <a:t> qué se valida, qué se controla.</a:t>
             </a:r>
           </a:p>
           <a:p>
             <a:pPr>
               <a:spcAft>
-                <a:spcPts val="800"/>
+                <a:spcPts val="400"/>
               </a:spcAft>
             </a:pPr>
             <a:r>
-              <a:rPr sz="1800">
+              <a:rPr sz="1900">
                 <a:solidFill>
                   <a:srgbClr val="000000"/>
                 </a:solidFill>
@@ -7164,32 +7403,32 @@
               <a:t>– </a:t>
             </a:r>
             <a:r>
-              <a:rPr b="1" sz="1800">
-                <a:solidFill>
-                  <a:srgbClr val="000000"/>
-                </a:solidFill>
-                <a:latin typeface="Arial"/>
-              </a:rPr>
-              <a:t>Medible:</a:t>
-            </a:r>
-            <a:r>
-              <a:rPr sz="1800">
-                <a:solidFill>
-                  <a:srgbClr val="000000"/>
-                </a:solidFill>
-                <a:latin typeface="Arial"/>
-              </a:rPr>
-              <a:t> 20 tablas, 3 vistas, 3 SP y 2 triggers operativos.</a:t>
+              <a:rPr b="1" sz="1900">
+                <a:solidFill>
+                  <a:srgbClr val="000000"/>
+                </a:solidFill>
+                <a:latin typeface="Arial"/>
+              </a:rPr>
+              <a:t>Mapear el proceso actual:</a:t>
+            </a:r>
+            <a:r>
+              <a:rPr sz="1900">
+                <a:solidFill>
+                  <a:srgbClr val="000000"/>
+                </a:solidFill>
+                <a:latin typeface="Arial"/>
+              </a:rPr>
+              <a:t> de la consulta a la venta y la reposición.</a:t>
             </a:r>
           </a:p>
           <a:p>
             <a:pPr>
               <a:spcAft>
-                <a:spcPts val="800"/>
+                <a:spcPts val="400"/>
               </a:spcAft>
             </a:pPr>
             <a:r>
-              <a:rPr sz="1800">
+              <a:rPr sz="1900">
                 <a:solidFill>
                   <a:srgbClr val="000000"/>
                 </a:solidFill>
@@ -7198,32 +7437,32 @@
               <a:t>– </a:t>
             </a:r>
             <a:r>
-              <a:rPr b="1" sz="1800">
-                <a:solidFill>
-                  <a:srgbClr val="000000"/>
-                </a:solidFill>
-                <a:latin typeface="Arial"/>
-              </a:rPr>
-              <a:t>Alcanzable:</a:t>
-            </a:r>
-            <a:r>
-              <a:rPr sz="1800">
-                <a:solidFill>
-                  <a:srgbClr val="000000"/>
-                </a:solidFill>
-                <a:latin typeface="Arial"/>
-              </a:rPr>
-              <a:t> MySQL + acceso desde Java (JDBC).</a:t>
+              <a:rPr b="1" sz="1900">
+                <a:solidFill>
+                  <a:srgbClr val="000000"/>
+                </a:solidFill>
+                <a:latin typeface="Arial"/>
+              </a:rPr>
+              <a:t>Estandarizar la operación:</a:t>
+            </a:r>
+            <a:r>
+              <a:rPr sz="1900">
+                <a:solidFill>
+                  <a:srgbClr val="000000"/>
+                </a:solidFill>
+                <a:latin typeface="Arial"/>
+              </a:rPr>
+              <a:t> un flujo único y ordenado.</a:t>
             </a:r>
           </a:p>
           <a:p>
             <a:pPr>
               <a:spcAft>
-                <a:spcPts val="800"/>
+                <a:spcPts val="400"/>
               </a:spcAft>
             </a:pPr>
             <a:r>
-              <a:rPr sz="1800">
+              <a:rPr sz="1900">
                 <a:solidFill>
                   <a:srgbClr val="000000"/>
                 </a:solidFill>
@@ -7232,32 +7471,32 @@
               <a:t>– </a:t>
             </a:r>
             <a:r>
-              <a:rPr b="1" sz="1800">
-                <a:solidFill>
-                  <a:srgbClr val="000000"/>
-                </a:solidFill>
-                <a:latin typeface="Arial"/>
-              </a:rPr>
-              <a:t>Relevante:</a:t>
-            </a:r>
-            <a:r>
-              <a:rPr sz="1800">
-                <a:solidFill>
-                  <a:srgbClr val="000000"/>
-                </a:solidFill>
-                <a:latin typeface="Arial"/>
-              </a:rPr>
-              <a:t> ataca las causas de riesgo clínico y pérdidas.</a:t>
+              <a:rPr b="1" sz="1900">
+                <a:solidFill>
+                  <a:srgbClr val="000000"/>
+                </a:solidFill>
+                <a:latin typeface="Arial"/>
+              </a:rPr>
+              <a:t>Centralizar la información:</a:t>
+            </a:r>
+            <a:r>
+              <a:rPr sz="1900">
+                <a:solidFill>
+                  <a:srgbClr val="000000"/>
+                </a:solidFill>
+                <a:latin typeface="Arial"/>
+              </a:rPr>
+              <a:t> una sola fuente de verdad.</a:t>
             </a:r>
           </a:p>
           <a:p>
             <a:pPr>
               <a:spcAft>
-                <a:spcPts val="800"/>
+                <a:spcPts val="400"/>
               </a:spcAft>
             </a:pPr>
             <a:r>
-              <a:rPr sz="1800">
+              <a:rPr sz="1900">
                 <a:solidFill>
                   <a:srgbClr val="000000"/>
                 </a:solidFill>
@@ -7266,22 +7505,56 @@
               <a:t>– </a:t>
             </a:r>
             <a:r>
-              <a:rPr b="1" sz="1800">
-                <a:solidFill>
-                  <a:srgbClr val="000000"/>
-                </a:solidFill>
-                <a:latin typeface="Arial"/>
-              </a:rPr>
-              <a:t>Temporal:</a:t>
-            </a:r>
-            <a:r>
-              <a:rPr sz="1800">
-                <a:solidFill>
-                  <a:srgbClr val="000000"/>
-                </a:solidFill>
-                <a:latin typeface="Arial"/>
-              </a:rPr>
-              <a:t> entregable al cierre del proyecto final.</a:t>
+              <a:rPr b="1" sz="1900">
+                <a:solidFill>
+                  <a:srgbClr val="000000"/>
+                </a:solidFill>
+                <a:latin typeface="Arial"/>
+              </a:rPr>
+              <a:t>Automatizar los procesos:</a:t>
+            </a:r>
+            <a:r>
+              <a:rPr sz="1900">
+                <a:solidFill>
+                  <a:srgbClr val="000000"/>
+                </a:solidFill>
+                <a:latin typeface="Arial"/>
+              </a:rPr>
+              <a:t> validaciones y registros sin intervención manual.</a:t>
+            </a:r>
+          </a:p>
+        </p:txBody>
+      </p:sp>
+      <p:sp>
+        <p:nvSpPr>
+          <p:cNvPr id="5" name="TextBox 4"/>
+          <p:cNvSpPr txBox="1"/>
+          <p:nvPr/>
+        </p:nvSpPr>
+        <p:spPr>
+          <a:xfrm>
+            <a:off x="640080" y="5303520"/>
+            <a:ext cx="10911535" cy="457200"/>
+          </a:xfrm>
+          <a:prstGeom prst="rect">
+            <a:avLst/>
+          </a:prstGeom>
+          <a:noFill/>
+        </p:spPr>
+        <p:txBody>
+          <a:bodyPr wrap="none">
+            <a:spAutoFit/>
+          </a:bodyPr>
+          <a:lstStyle/>
+          <a:p>
+            <a:r>
+              <a:rPr i="1" sz="1400">
+                <a:solidFill>
+                  <a:srgbClr val="404040"/>
+                </a:solidFill>
+                <a:latin typeface="Arial"/>
+              </a:rPr>
+              <a:t>Primero la operación, luego la tecnología.</a:t>
             </a:r>
           </a:p>
         </p:txBody>
@@ -7389,7 +7662,7 @@
         </p:nvSpPr>
         <p:spPr>
           <a:xfrm>
-            <a:off x="640080" y="411480"/>
+            <a:off x="640080" y="365760"/>
             <a:ext cx="10911535" cy="822960"/>
           </a:xfrm>
           <a:prstGeom prst="rect">
@@ -7404,13 +7677,13 @@
           <a:lstStyle/>
           <a:p>
             <a:r>
-              <a:rPr sz="3000" b="1">
-                <a:solidFill>
-                  <a:srgbClr val="000000"/>
-                </a:solidFill>
-                <a:latin typeface="Arial"/>
-              </a:rPr>
-              <a:t>Estrategia: atacar la causa raíz operativa</a:t>
+              <a:rPr sz="2800" b="1">
+                <a:solidFill>
+                  <a:srgbClr val="000000"/>
+                </a:solidFill>
+                <a:latin typeface="Arial"/>
+              </a:rPr>
+              <a:t>¿Cuál es nuestra solución tecnológica?</a:t>
             </a:r>
           </a:p>
         </p:txBody>
@@ -7423,7 +7696,7 @@
         </p:nvCxnSpPr>
         <p:spPr>
           <a:xfrm>
-            <a:off x="640080" y="1261872"/>
+            <a:off x="640080" y="1170432"/>
             <a:ext cx="4754880" cy="0"/>
           </a:xfrm>
           <a:prstGeom prst="line">
@@ -7459,7 +7732,7 @@
         <p:spPr>
           <a:xfrm>
             <a:off x="640080" y="1463040"/>
-            <a:ext cx="10911535" cy="457200"/>
+            <a:ext cx="10911535" cy="3108960"/>
           </a:xfrm>
           <a:prstGeom prst="rect">
             <a:avLst/>
@@ -7472,14 +7745,105 @@
           </a:bodyPr>
           <a:lstStyle/>
           <a:p>
-            <a:r>
-              <a:rPr b="1" sz="1800">
-                <a:solidFill>
-                  <a:srgbClr val="000000"/>
-                </a:solidFill>
-                <a:latin typeface="Arial"/>
-              </a:rPr>
-              <a:t>Primero la operación, luego la tecnología.</a:t>
+            <a:pPr>
+              <a:spcAft>
+                <a:spcPts val="400"/>
+              </a:spcAft>
+            </a:pPr>
+            <a:r>
+              <a:rPr sz="1900">
+                <a:solidFill>
+                  <a:srgbClr val="000000"/>
+                </a:solidFill>
+                <a:latin typeface="Arial"/>
+              </a:rPr>
+              <a:t>– </a:t>
+            </a:r>
+            <a:r>
+              <a:rPr b="1" sz="1900">
+                <a:solidFill>
+                  <a:srgbClr val="000000"/>
+                </a:solidFill>
+                <a:latin typeface="Arial"/>
+              </a:rPr>
+              <a:t>Base de datos relacional en MySQL:</a:t>
+            </a:r>
+            <a:r>
+              <a:rPr sz="1900">
+                <a:solidFill>
+                  <a:srgbClr val="000000"/>
+                </a:solidFill>
+                <a:latin typeface="Arial"/>
+              </a:rPr>
+              <a:t> centraliza toda la información.</a:t>
+            </a:r>
+          </a:p>
+          <a:p>
+            <a:pPr>
+              <a:spcAft>
+                <a:spcPts val="400"/>
+              </a:spcAft>
+            </a:pPr>
+            <a:r>
+              <a:rPr sz="1900">
+                <a:solidFill>
+                  <a:srgbClr val="000000"/>
+                </a:solidFill>
+                <a:latin typeface="Arial"/>
+              </a:rPr>
+              <a:t>– </a:t>
+            </a:r>
+            <a:r>
+              <a:rPr b="1" sz="1900">
+                <a:solidFill>
+                  <a:srgbClr val="000000"/>
+                </a:solidFill>
+                <a:latin typeface="Arial"/>
+              </a:rPr>
+              <a:t>Modelo Entidad-Relación:</a:t>
+            </a:r>
+            <a:r>
+              <a:rPr sz="1900">
+                <a:solidFill>
+                  <a:srgbClr val="000000"/>
+                </a:solidFill>
+                <a:latin typeface="Arial"/>
+              </a:rPr>
+              <a:t> 20 tablas con claves y relaciones definidas.</a:t>
+            </a:r>
+          </a:p>
+          <a:p>
+            <a:pPr>
+              <a:spcAft>
+                <a:spcPts val="400"/>
+              </a:spcAft>
+            </a:pPr>
+            <a:r>
+              <a:rPr sz="1900">
+                <a:solidFill>
+                  <a:srgbClr val="000000"/>
+                </a:solidFill>
+                <a:latin typeface="Arial"/>
+              </a:rPr>
+              <a:t>– </a:t>
+            </a:r>
+            <a:r>
+              <a:rPr b="1" sz="1900">
+                <a:solidFill>
+                  <a:srgbClr val="000000"/>
+                </a:solidFill>
+                <a:latin typeface="Arial"/>
+              </a:rPr>
+              <a:t>Integración de consultorio y farmacia:</a:t>
+            </a:r>
+            <a:r>
+              <a:rPr sz="1900">
+                <a:solidFill>
+                  <a:srgbClr val="000000"/>
+                </a:solidFill>
+                <a:latin typeface="Arial"/>
+              </a:rPr>
+              <a:t> un solo sistema, sin islas de datos.</a:t>
             </a:r>
           </a:p>
         </p:txBody>
@@ -7492,8 +7856,8 @@
         </p:nvSpPr>
         <p:spPr>
           <a:xfrm>
-            <a:off x="640080" y="2011680"/>
-            <a:ext cx="10911535" cy="3657600"/>
+            <a:off x="640080" y="4754880"/>
+            <a:ext cx="10911535" cy="457200"/>
           </a:xfrm>
           <a:prstGeom prst="rect">
             <a:avLst/>
@@ -7501,56 +7865,19 @@
           <a:noFill/>
         </p:spPr>
         <p:txBody>
-          <a:bodyPr wrap="square">
+          <a:bodyPr wrap="none">
             <a:spAutoFit/>
           </a:bodyPr>
           <a:lstStyle/>
           <a:p>
-            <a:pPr>
-              <a:spcAft>
-                <a:spcPts val="800"/>
-              </a:spcAft>
-            </a:pPr>
-            <a:r>
-              <a:rPr sz="2000">
-                <a:solidFill>
-                  <a:srgbClr val="000000"/>
-                </a:solidFill>
-                <a:latin typeface="Arial"/>
-              </a:rPr>
-              <a:t>– Estandarizar el flujo: paciente → consulta → receta → surtido → venta → inventario → reposición.</a:t>
-            </a:r>
-          </a:p>
-          <a:p>
-            <a:pPr>
-              <a:spcAft>
-                <a:spcPts val="800"/>
-              </a:spcAft>
-            </a:pPr>
-            <a:r>
-              <a:rPr sz="2000">
-                <a:solidFill>
-                  <a:srgbClr val="000000"/>
-                </a:solidFill>
-                <a:latin typeface="Arial"/>
-              </a:rPr>
-              <a:t>– Definir reglas de negocio: vigencia de cédula médica, control de alergias/interacciones, stock mínimo y caducidad.</a:t>
-            </a:r>
-          </a:p>
-          <a:p>
-            <a:pPr>
-              <a:spcAft>
-                <a:spcPts val="800"/>
-              </a:spcAft>
-            </a:pPr>
-            <a:r>
-              <a:rPr sz="2000">
-                <a:solidFill>
-                  <a:srgbClr val="000000"/>
-                </a:solidFill>
-                <a:latin typeface="Arial"/>
-              </a:rPr>
-              <a:t>– Después, llevar esas reglas a la base de datos como restricciones, procedimientos y triggers.</a:t>
+            <a:r>
+              <a:rPr i="1" sz="1400">
+                <a:solidFill>
+                  <a:srgbClr val="404040"/>
+                </a:solidFill>
+                <a:latin typeface="Arial"/>
+              </a:rPr>
+              <a:t>Evidencia: Modelo Entidad-Relación (siguiente diapositiva).</a:t>
             </a:r>
           </a:p>
         </p:txBody>
@@ -7633,329 +7960,6 @@
 </file>
 
 <file path=ppt/slides/slide8.xml><?xml version="1.0" encoding="utf-8"?>
-<p:sld xmlns:a="http://schemas.openxmlformats.org/drawingml/2006/main" xmlns:p="http://schemas.openxmlformats.org/presentationml/2006/main" xmlns:r="http://schemas.openxmlformats.org/officeDocument/2006/relationships">
-  <p:cSld>
-    <p:bg>
-      <p:bgPr>
-        <a:solidFill>
-          <a:srgbClr val="FFFFFF"/>
-        </a:solidFill>
-        <a:effectLst/>
-      </p:bgPr>
-    </p:bg>
-    <p:spTree>
-      <p:nvGrpSpPr>
-        <p:cNvPr id="1" name=""/>
-        <p:cNvGrpSpPr/>
-        <p:nvPr/>
-      </p:nvGrpSpPr>
-      <p:grpSpPr/>
-      <p:sp>
-        <p:nvSpPr>
-          <p:cNvPr id="2" name="TextBox 1"/>
-          <p:cNvSpPr txBox="1"/>
-          <p:nvPr/>
-        </p:nvSpPr>
-        <p:spPr>
-          <a:xfrm>
-            <a:off x="640080" y="411480"/>
-            <a:ext cx="10911535" cy="822960"/>
-          </a:xfrm>
-          <a:prstGeom prst="rect">
-            <a:avLst/>
-          </a:prstGeom>
-          <a:noFill/>
-        </p:spPr>
-        <p:txBody>
-          <a:bodyPr wrap="square">
-            <a:spAutoFit/>
-          </a:bodyPr>
-          <a:lstStyle/>
-          <a:p>
-            <a:r>
-              <a:rPr sz="3000" b="1">
-                <a:solidFill>
-                  <a:srgbClr val="000000"/>
-                </a:solidFill>
-                <a:latin typeface="Arial"/>
-              </a:rPr>
-              <a:t>¿Cuál es la importancia de...?</a:t>
-            </a:r>
-          </a:p>
-        </p:txBody>
-      </p:sp>
-      <p:cxnSp>
-        <p:nvCxnSpPr>
-          <p:cNvPr id="3" name="Connector 2"/>
-          <p:cNvCxnSpPr/>
-          <p:nvPr/>
-        </p:nvCxnSpPr>
-        <p:spPr>
-          <a:xfrm>
-            <a:off x="640080" y="1261872"/>
-            <a:ext cx="4754880" cy="0"/>
-          </a:xfrm>
-          <a:prstGeom prst="line">
-            <a:avLst/>
-          </a:prstGeom>
-          <a:ln w="19050">
-            <a:solidFill>
-              <a:srgbClr val="000000"/>
-            </a:solidFill>
-          </a:ln>
-        </p:spPr>
-        <p:style>
-          <a:lnRef idx="2">
-            <a:schemeClr val="accent1"/>
-          </a:lnRef>
-          <a:fillRef idx="0">
-            <a:schemeClr val="accent1"/>
-          </a:fillRef>
-          <a:effectRef idx="1">
-            <a:schemeClr val="accent1"/>
-          </a:effectRef>
-          <a:fontRef idx="minor">
-            <a:schemeClr val="tx1"/>
-          </a:fontRef>
-        </p:style>
-      </p:cxnSp>
-      <p:sp>
-        <p:nvSpPr>
-          <p:cNvPr id="4" name="TextBox 3"/>
-          <p:cNvSpPr txBox="1"/>
-          <p:nvPr/>
-        </p:nvSpPr>
-        <p:spPr>
-          <a:xfrm>
-            <a:off x="640080" y="1554480"/>
-            <a:ext cx="10911535" cy="4754880"/>
-          </a:xfrm>
-          <a:prstGeom prst="rect">
-            <a:avLst/>
-          </a:prstGeom>
-          <a:noFill/>
-        </p:spPr>
-        <p:txBody>
-          <a:bodyPr wrap="square">
-            <a:spAutoFit/>
-          </a:bodyPr>
-          <a:lstStyle/>
-          <a:p>
-            <a:pPr>
-              <a:spcAft>
-                <a:spcPts val="800"/>
-              </a:spcAft>
-            </a:pPr>
-            <a:r>
-              <a:rPr sz="2000">
-                <a:solidFill>
-                  <a:srgbClr val="000000"/>
-                </a:solidFill>
-                <a:latin typeface="Arial"/>
-              </a:rPr>
-              <a:t>– </a:t>
-            </a:r>
-            <a:r>
-              <a:rPr b="1" sz="2000">
-                <a:solidFill>
-                  <a:srgbClr val="000000"/>
-                </a:solidFill>
-                <a:latin typeface="Arial"/>
-              </a:rPr>
-              <a:t>Entender las reglas de negocio:</a:t>
-            </a:r>
-            <a:r>
-              <a:rPr sz="2000">
-                <a:solidFill>
-                  <a:srgbClr val="000000"/>
-                </a:solidFill>
-                <a:latin typeface="Arial"/>
-              </a:rPr>
-              <a:t> evita errores clínicos y define qué debe validar el sistema.</a:t>
-            </a:r>
-          </a:p>
-          <a:p>
-            <a:pPr>
-              <a:spcAft>
-                <a:spcPts val="800"/>
-              </a:spcAft>
-            </a:pPr>
-            <a:r>
-              <a:rPr sz="2000">
-                <a:solidFill>
-                  <a:srgbClr val="000000"/>
-                </a:solidFill>
-                <a:latin typeface="Arial"/>
-              </a:rPr>
-              <a:t>– </a:t>
-            </a:r>
-            <a:r>
-              <a:rPr b="1" sz="2000">
-                <a:solidFill>
-                  <a:srgbClr val="000000"/>
-                </a:solidFill>
-                <a:latin typeface="Arial"/>
-              </a:rPr>
-              <a:t>Mapear el flujo de información:</a:t>
-            </a:r>
-            <a:r>
-              <a:rPr sz="2000">
-                <a:solidFill>
-                  <a:srgbClr val="000000"/>
-                </a:solidFill>
-                <a:latin typeface="Arial"/>
-              </a:rPr>
-              <a:t> muestra qué datos se comparten entre consultorio, farmacia y compras.</a:t>
-            </a:r>
-          </a:p>
-          <a:p>
-            <a:pPr>
-              <a:spcAft>
-                <a:spcPts val="800"/>
-              </a:spcAft>
-            </a:pPr>
-            <a:r>
-              <a:rPr sz="2000">
-                <a:solidFill>
-                  <a:srgbClr val="000000"/>
-                </a:solidFill>
-                <a:latin typeface="Arial"/>
-              </a:rPr>
-              <a:t>– </a:t>
-            </a:r>
-            <a:r>
-              <a:rPr b="1" sz="2000">
-                <a:solidFill>
-                  <a:srgbClr val="000000"/>
-                </a:solidFill>
-                <a:latin typeface="Arial"/>
-              </a:rPr>
-              <a:t>Integrar operación y tecnología:</a:t>
-            </a:r>
-            <a:r>
-              <a:rPr sz="2000">
-                <a:solidFill>
-                  <a:srgbClr val="000000"/>
-                </a:solidFill>
-                <a:latin typeface="Arial"/>
-              </a:rPr>
-              <a:t> una sola fuente de verdad, sin islas de información.</a:t>
-            </a:r>
-          </a:p>
-          <a:p>
-            <a:pPr>
-              <a:spcAft>
-                <a:spcPts val="800"/>
-              </a:spcAft>
-            </a:pPr>
-            <a:r>
-              <a:rPr sz="2000">
-                <a:solidFill>
-                  <a:srgbClr val="000000"/>
-                </a:solidFill>
-                <a:latin typeface="Arial"/>
-              </a:rPr>
-              <a:t>– </a:t>
-            </a:r>
-            <a:r>
-              <a:rPr b="1" sz="2000">
-                <a:solidFill>
-                  <a:srgbClr val="000000"/>
-                </a:solidFill>
-                <a:latin typeface="Arial"/>
-              </a:rPr>
-              <a:t>Gestionar la ejecución de la estrategia:</a:t>
-            </a:r>
-            <a:r>
-              <a:rPr sz="2000">
-                <a:solidFill>
-                  <a:srgbClr val="000000"/>
-                </a:solidFill>
-                <a:latin typeface="Arial"/>
-              </a:rPr>
-              <a:t> vistas, SP y triggers garantizan que las reglas se cumplan.</a:t>
-            </a:r>
-          </a:p>
-        </p:txBody>
-      </p:sp>
-      <p:sp>
-        <p:nvSpPr>
-          <p:cNvPr id="5" name="TextBox 4"/>
-          <p:cNvSpPr txBox="1"/>
-          <p:nvPr/>
-        </p:nvSpPr>
-        <p:spPr>
-          <a:xfrm>
-            <a:off x="640080" y="6400800"/>
-            <a:ext cx="10911535" cy="320040"/>
-          </a:xfrm>
-          <a:prstGeom prst="rect">
-            <a:avLst/>
-          </a:prstGeom>
-          <a:noFill/>
-        </p:spPr>
-        <p:txBody>
-          <a:bodyPr wrap="none">
-            <a:spAutoFit/>
-          </a:bodyPr>
-          <a:lstStyle/>
-          <a:p>
-            <a:r>
-              <a:rPr sz="1000">
-                <a:solidFill>
-                  <a:srgbClr val="404040"/>
-                </a:solidFill>
-                <a:latin typeface="Arial"/>
-              </a:rPr>
-              <a:t>Farmacia con Consultorio Médico</a:t>
-            </a:r>
-          </a:p>
-        </p:txBody>
-      </p:sp>
-      <p:sp>
-        <p:nvSpPr>
-          <p:cNvPr id="6" name="TextBox 5"/>
-          <p:cNvSpPr txBox="1"/>
-          <p:nvPr/>
-        </p:nvSpPr>
-        <p:spPr>
-          <a:xfrm>
-            <a:off x="10637215" y="6400800"/>
-            <a:ext cx="914400" cy="320040"/>
-          </a:xfrm>
-          <a:prstGeom prst="rect">
-            <a:avLst/>
-          </a:prstGeom>
-          <a:noFill/>
-        </p:spPr>
-        <p:txBody>
-          <a:bodyPr wrap="none">
-            <a:spAutoFit/>
-          </a:bodyPr>
-          <a:lstStyle/>
-          <a:p>
-            <a:pPr algn="r"/>
-            <a:r>
-              <a:rPr sz="1000">
-                <a:solidFill>
-                  <a:srgbClr val="404040"/>
-                </a:solidFill>
-                <a:latin typeface="Arial"/>
-              </a:rPr>
-              <a:t>7</a:t>
-            </a:r>
-          </a:p>
-        </p:txBody>
-      </p:sp>
-    </p:spTree>
-  </p:cSld>
-  <p:clrMapOvr>
-    <a:masterClrMapping/>
-  </p:clrMapOvr>
-</p:sld>
-</file>
-
-<file path=ppt/slides/slide9.xml><?xml version="1.0" encoding="utf-8"?>
 <p:sld xmlns:a="http://schemas.openxmlformats.org/drawingml/2006/main" xmlns:p="http://schemas.openxmlformats.org/presentationml/2006/main" xmlns:r="http://schemas.openxmlformats.org/officeDocument/2006/relationships">
   <p:cSld>
     <p:bg>
@@ -7997,6 +8001,333 @@
           </a:prstGeom>
         </p:spPr>
       </p:pic>
+    </p:spTree>
+  </p:cSld>
+  <p:clrMapOvr>
+    <a:masterClrMapping/>
+  </p:clrMapOvr>
+</p:sld>
+</file>
+
+<file path=ppt/slides/slide9.xml><?xml version="1.0" encoding="utf-8"?>
+<p:sld xmlns:a="http://schemas.openxmlformats.org/drawingml/2006/main" xmlns:p="http://schemas.openxmlformats.org/presentationml/2006/main" xmlns:r="http://schemas.openxmlformats.org/officeDocument/2006/relationships">
+  <p:cSld>
+    <p:bg>
+      <p:bgPr>
+        <a:solidFill>
+          <a:srgbClr val="FFFFFF"/>
+        </a:solidFill>
+        <a:effectLst/>
+      </p:bgPr>
+    </p:bg>
+    <p:spTree>
+      <p:nvGrpSpPr>
+        <p:cNvPr id="1" name=""/>
+        <p:cNvGrpSpPr/>
+        <p:nvPr/>
+      </p:nvGrpSpPr>
+      <p:grpSpPr/>
+      <p:sp>
+        <p:nvSpPr>
+          <p:cNvPr id="2" name="TextBox 1"/>
+          <p:cNvSpPr txBox="1"/>
+          <p:nvPr/>
+        </p:nvSpPr>
+        <p:spPr>
+          <a:xfrm>
+            <a:off x="640080" y="365760"/>
+            <a:ext cx="10911535" cy="822960"/>
+          </a:xfrm>
+          <a:prstGeom prst="rect">
+            <a:avLst/>
+          </a:prstGeom>
+          <a:noFill/>
+        </p:spPr>
+        <p:txBody>
+          <a:bodyPr wrap="square">
+            <a:spAutoFit/>
+          </a:bodyPr>
+          <a:lstStyle/>
+          <a:p>
+            <a:r>
+              <a:rPr sz="2800" b="1">
+                <a:solidFill>
+                  <a:srgbClr val="000000"/>
+                </a:solidFill>
+                <a:latin typeface="Arial"/>
+              </a:rPr>
+              <a:t>¿Cómo se gestionan los datos?</a:t>
+            </a:r>
+          </a:p>
+        </p:txBody>
+      </p:sp>
+      <p:cxnSp>
+        <p:nvCxnSpPr>
+          <p:cNvPr id="3" name="Connector 2"/>
+          <p:cNvCxnSpPr/>
+          <p:nvPr/>
+        </p:nvCxnSpPr>
+        <p:spPr>
+          <a:xfrm>
+            <a:off x="640080" y="1170432"/>
+            <a:ext cx="4754880" cy="0"/>
+          </a:xfrm>
+          <a:prstGeom prst="line">
+            <a:avLst/>
+          </a:prstGeom>
+          <a:ln w="19050">
+            <a:solidFill>
+              <a:srgbClr val="000000"/>
+            </a:solidFill>
+          </a:ln>
+        </p:spPr>
+        <p:style>
+          <a:lnRef idx="2">
+            <a:schemeClr val="accent1"/>
+          </a:lnRef>
+          <a:fillRef idx="0">
+            <a:schemeClr val="accent1"/>
+          </a:fillRef>
+          <a:effectRef idx="1">
+            <a:schemeClr val="accent1"/>
+          </a:effectRef>
+          <a:fontRef idx="minor">
+            <a:schemeClr val="tx1"/>
+          </a:fontRef>
+        </p:style>
+      </p:cxnSp>
+      <p:sp>
+        <p:nvSpPr>
+          <p:cNvPr id="4" name="TextBox 3"/>
+          <p:cNvSpPr txBox="1"/>
+          <p:nvPr/>
+        </p:nvSpPr>
+        <p:spPr>
+          <a:xfrm>
+            <a:off x="640080" y="1371600"/>
+            <a:ext cx="10911535" cy="4937760"/>
+          </a:xfrm>
+          <a:prstGeom prst="rect">
+            <a:avLst/>
+          </a:prstGeom>
+          <a:noFill/>
+        </p:spPr>
+        <p:txBody>
+          <a:bodyPr wrap="square">
+            <a:spAutoFit/>
+          </a:bodyPr>
+          <a:lstStyle/>
+          <a:p>
+            <a:pPr>
+              <a:spcBef>
+                <a:spcPts val="600"/>
+              </a:spcBef>
+              <a:spcAft>
+                <a:spcPts val="200"/>
+              </a:spcAft>
+            </a:pPr>
+            <a:r>
+              <a:rPr b="1" sz="1700">
+                <a:solidFill>
+                  <a:srgbClr val="000000"/>
+                </a:solidFill>
+                <a:latin typeface="Arial"/>
+              </a:rPr>
+              <a:t>Flujo de la información</a:t>
+            </a:r>
+          </a:p>
+          <a:p>
+            <a:pPr lvl="1">
+              <a:spcAft>
+                <a:spcPts val="400"/>
+              </a:spcAft>
+            </a:pPr>
+            <a:r>
+              <a:rPr sz="1600">
+                <a:solidFill>
+                  <a:srgbClr val="000000"/>
+                </a:solidFill>
+                <a:latin typeface="Arial"/>
+              </a:rPr>
+              <a:t>– Paciente → consulta → receta → surtido → venta → inventario → reposición.</a:t>
+            </a:r>
+          </a:p>
+          <a:p>
+            <a:pPr>
+              <a:spcBef>
+                <a:spcPts val="600"/>
+              </a:spcBef>
+              <a:spcAft>
+                <a:spcPts val="200"/>
+              </a:spcAft>
+            </a:pPr>
+            <a:r>
+              <a:rPr b="1" sz="1700">
+                <a:solidFill>
+                  <a:srgbClr val="000000"/>
+                </a:solidFill>
+                <a:latin typeface="Arial"/>
+              </a:rPr>
+              <a:t>Información clínica</a:t>
+            </a:r>
+          </a:p>
+          <a:p>
+            <a:pPr lvl="1">
+              <a:spcAft>
+                <a:spcPts val="400"/>
+              </a:spcAft>
+            </a:pPr>
+            <a:r>
+              <a:rPr sz="1600">
+                <a:solidFill>
+                  <a:srgbClr val="000000"/>
+                </a:solidFill>
+                <a:latin typeface="Arial"/>
+              </a:rPr>
+              <a:t>– Historial, diagnósticos, alergias y contraindicaciones del paciente.</a:t>
+            </a:r>
+          </a:p>
+          <a:p>
+            <a:pPr>
+              <a:spcBef>
+                <a:spcPts val="600"/>
+              </a:spcBef>
+              <a:spcAft>
+                <a:spcPts val="200"/>
+              </a:spcAft>
+            </a:pPr>
+            <a:r>
+              <a:rPr b="1" sz="1700">
+                <a:solidFill>
+                  <a:srgbClr val="000000"/>
+                </a:solidFill>
+                <a:latin typeface="Arial"/>
+              </a:rPr>
+              <a:t>Recetas y medicamentos</a:t>
+            </a:r>
+          </a:p>
+          <a:p>
+            <a:pPr lvl="1">
+              <a:spcAft>
+                <a:spcPts val="400"/>
+              </a:spcAft>
+            </a:pPr>
+            <a:r>
+              <a:rPr sz="1600">
+                <a:solidFill>
+                  <a:srgbClr val="000000"/>
+                </a:solidFill>
+                <a:latin typeface="Arial"/>
+              </a:rPr>
+              <a:t>– Recetas vinculadas a consulta, medicamento, dosis y duración.</a:t>
+            </a:r>
+          </a:p>
+          <a:p>
+            <a:pPr>
+              <a:spcBef>
+                <a:spcPts val="600"/>
+              </a:spcBef>
+              <a:spcAft>
+                <a:spcPts val="200"/>
+              </a:spcAft>
+            </a:pPr>
+            <a:r>
+              <a:rPr b="1" sz="1700">
+                <a:solidFill>
+                  <a:srgbClr val="000000"/>
+                </a:solidFill>
+                <a:latin typeface="Arial"/>
+              </a:rPr>
+              <a:t>Inventario y ventas</a:t>
+            </a:r>
+          </a:p>
+          <a:p>
+            <a:pPr lvl="1">
+              <a:spcAft>
+                <a:spcPts val="400"/>
+              </a:spcAft>
+            </a:pPr>
+            <a:r>
+              <a:rPr sz="1600">
+                <a:solidFill>
+                  <a:srgbClr val="000000"/>
+                </a:solidFill>
+                <a:latin typeface="Arial"/>
+              </a:rPr>
+              <a:t>– Stock por lote, caducidades, ventas y su vínculo con la receta.</a:t>
+            </a:r>
+          </a:p>
+        </p:txBody>
+      </p:sp>
+      <p:sp>
+        <p:nvSpPr>
+          <p:cNvPr id="5" name="TextBox 4"/>
+          <p:cNvSpPr txBox="1"/>
+          <p:nvPr/>
+        </p:nvSpPr>
+        <p:spPr>
+          <a:xfrm>
+            <a:off x="640080" y="6400800"/>
+            <a:ext cx="10911535" cy="320040"/>
+          </a:xfrm>
+          <a:prstGeom prst="rect">
+            <a:avLst/>
+          </a:prstGeom>
+          <a:noFill/>
+        </p:spPr>
+        <p:txBody>
+          <a:bodyPr wrap="none">
+            <a:spAutoFit/>
+          </a:bodyPr>
+          <a:lstStyle/>
+          <a:p>
+            <a:r>
+              <a:rPr sz="1000">
+                <a:solidFill>
+                  <a:srgbClr val="404040"/>
+                </a:solidFill>
+                <a:latin typeface="Arial"/>
+              </a:rPr>
+              <a:t>Farmacia con Consultorio Médico</a:t>
+            </a:r>
+          </a:p>
+        </p:txBody>
+      </p:sp>
+      <p:sp>
+        <p:nvSpPr>
+          <p:cNvPr id="6" name="TextBox 5"/>
+          <p:cNvSpPr txBox="1"/>
+          <p:nvPr/>
+        </p:nvSpPr>
+        <p:spPr>
+          <a:xfrm>
+            <a:off x="10637215" y="6400800"/>
+            <a:ext cx="914400" cy="320040"/>
+          </a:xfrm>
+          <a:prstGeom prst="rect">
+            <a:avLst/>
+          </a:prstGeom>
+          <a:noFill/>
+        </p:spPr>
+        <p:txBody>
+          <a:bodyPr wrap="none">
+            <a:spAutoFit/>
+          </a:bodyPr>
+          <a:lstStyle/>
+          <a:p>
+            <a:pPr algn="r"/>
+            <a:r>
+              <a:rPr sz="1000">
+                <a:solidFill>
+                  <a:srgbClr val="404040"/>
+                </a:solidFill>
+                <a:latin typeface="Arial"/>
+              </a:rPr>
+              <a:t>7</a:t>
+            </a:r>
+          </a:p>
+        </p:txBody>
+      </p:sp>
     </p:spTree>
   </p:cSld>
   <p:clrMapOvr>

</xml_diff>